<commit_message>
Update 295 MIORENA MAFY TSARA.pptx
</commit_message>
<xml_diff>
--- a/data/FFPM/295 MIORENA MAFY TSARA.pptx
+++ b/data/FFPM/295 MIORENA MAFY TSARA.pptx
@@ -111,6 +111,22 @@
       </a:defRPr>
     </a:lvl9pPr>
   </p:defaultTextStyle>
+  <p:extLst>
+    <p:ext uri="{EFAFB233-063F-42B5-8137-9DF3F51BA10A}">
+      <p15:sldGuideLst xmlns:p15="http://schemas.microsoft.com/office/powerpoint/2012/main">
+        <p15:guide id="1" orient="horz" pos="2160">
+          <p15:clr>
+            <a:srgbClr val="A4A3A4"/>
+          </p15:clr>
+        </p15:guide>
+        <p15:guide id="2" pos="2880">
+          <p15:clr>
+            <a:srgbClr val="A4A3A4"/>
+          </p15:clr>
+        </p15:guide>
+      </p15:sldGuideLst>
+    </p:ext>
+  </p:extLst>
 </p:presentation>
 </file>
 
@@ -152,7 +168,7 @@
           <a:lstStyle/>
           <a:p>
             <a:r>
-              <a:rPr lang="fr-FR" smtClean="0"/>
+              <a:rPr lang="fr-FR"/>
               <a:t>Cliquez pour modifier le style du titre</a:t>
             </a:r>
             <a:endParaRPr lang="fr-BE"/>
@@ -271,7 +287,7 @@
           </a:lstStyle>
           <a:p>
             <a:r>
-              <a:rPr lang="fr-FR" smtClean="0"/>
+              <a:rPr lang="fr-FR"/>
               <a:t>Cliquez pour modifier le style des sous-titres du masque</a:t>
             </a:r>
             <a:endParaRPr lang="fr-BE"/>
@@ -296,7 +312,7 @@
             <a:fld id="{AA309A6D-C09C-4548-B29A-6CF363A7E532}" type="datetimeFigureOut">
               <a:rPr lang="fr-FR" smtClean="0"/>
               <a:pPr/>
-              <a:t>12/10/2014</a:t>
+              <a:t>02/08/2025</a:t>
             </a:fld>
             <a:endParaRPr lang="fr-BE"/>
           </a:p>
@@ -386,7 +402,7 @@
           <a:lstStyle/>
           <a:p>
             <a:r>
-              <a:rPr lang="fr-FR" smtClean="0"/>
+              <a:rPr lang="fr-FR"/>
               <a:t>Cliquez pour modifier le style du titre</a:t>
             </a:r>
             <a:endParaRPr lang="fr-BE"/>
@@ -410,35 +426,35 @@
           <a:p>
             <a:pPr lvl="0"/>
             <a:r>
-              <a:rPr lang="fr-FR" smtClean="0"/>
+              <a:rPr lang="fr-FR"/>
               <a:t>Cliquez pour modifier les styles du texte du masque</a:t>
             </a:r>
           </a:p>
           <a:p>
             <a:pPr lvl="1"/>
             <a:r>
-              <a:rPr lang="fr-FR" smtClean="0"/>
+              <a:rPr lang="fr-FR"/>
               <a:t>Deuxième niveau</a:t>
             </a:r>
           </a:p>
           <a:p>
             <a:pPr lvl="2"/>
             <a:r>
-              <a:rPr lang="fr-FR" smtClean="0"/>
+              <a:rPr lang="fr-FR"/>
               <a:t>Troisième niveau</a:t>
             </a:r>
           </a:p>
           <a:p>
             <a:pPr lvl="3"/>
             <a:r>
-              <a:rPr lang="fr-FR" smtClean="0"/>
+              <a:rPr lang="fr-FR"/>
               <a:t>Quatrième niveau</a:t>
             </a:r>
           </a:p>
           <a:p>
             <a:pPr lvl="4"/>
             <a:r>
-              <a:rPr lang="fr-FR" smtClean="0"/>
+              <a:rPr lang="fr-FR"/>
               <a:t>Cinquième niveau</a:t>
             </a:r>
             <a:endParaRPr lang="fr-BE"/>
@@ -463,7 +479,7 @@
             <a:fld id="{AA309A6D-C09C-4548-B29A-6CF363A7E532}" type="datetimeFigureOut">
               <a:rPr lang="fr-FR" smtClean="0"/>
               <a:pPr/>
-              <a:t>12/10/2014</a:t>
+              <a:t>02/08/2025</a:t>
             </a:fld>
             <a:endParaRPr lang="fr-BE"/>
           </a:p>
@@ -558,7 +574,7 @@
           <a:lstStyle/>
           <a:p>
             <a:r>
-              <a:rPr lang="fr-FR" smtClean="0"/>
+              <a:rPr lang="fr-FR"/>
               <a:t>Cliquez pour modifier le style du titre</a:t>
             </a:r>
             <a:endParaRPr lang="fr-BE"/>
@@ -587,35 +603,35 @@
           <a:p>
             <a:pPr lvl="0"/>
             <a:r>
-              <a:rPr lang="fr-FR" smtClean="0"/>
+              <a:rPr lang="fr-FR"/>
               <a:t>Cliquez pour modifier les styles du texte du masque</a:t>
             </a:r>
           </a:p>
           <a:p>
             <a:pPr lvl="1"/>
             <a:r>
-              <a:rPr lang="fr-FR" smtClean="0"/>
+              <a:rPr lang="fr-FR"/>
               <a:t>Deuxième niveau</a:t>
             </a:r>
           </a:p>
           <a:p>
             <a:pPr lvl="2"/>
             <a:r>
-              <a:rPr lang="fr-FR" smtClean="0"/>
+              <a:rPr lang="fr-FR"/>
               <a:t>Troisième niveau</a:t>
             </a:r>
           </a:p>
           <a:p>
             <a:pPr lvl="3"/>
             <a:r>
-              <a:rPr lang="fr-FR" smtClean="0"/>
+              <a:rPr lang="fr-FR"/>
               <a:t>Quatrième niveau</a:t>
             </a:r>
           </a:p>
           <a:p>
             <a:pPr lvl="4"/>
             <a:r>
-              <a:rPr lang="fr-FR" smtClean="0"/>
+              <a:rPr lang="fr-FR"/>
               <a:t>Cinquième niveau</a:t>
             </a:r>
             <a:endParaRPr lang="fr-BE"/>
@@ -640,7 +656,7 @@
             <a:fld id="{AA309A6D-C09C-4548-B29A-6CF363A7E532}" type="datetimeFigureOut">
               <a:rPr lang="fr-FR" smtClean="0"/>
               <a:pPr/>
-              <a:t>12/10/2014</a:t>
+              <a:t>02/08/2025</a:t>
             </a:fld>
             <a:endParaRPr lang="fr-BE"/>
           </a:p>
@@ -730,7 +746,7 @@
           <a:lstStyle/>
           <a:p>
             <a:r>
-              <a:rPr lang="fr-FR" smtClean="0"/>
+              <a:rPr lang="fr-FR"/>
               <a:t>Cliquez pour modifier le style du titre</a:t>
             </a:r>
             <a:endParaRPr lang="fr-BE"/>
@@ -754,35 +770,35 @@
           <a:p>
             <a:pPr lvl="0"/>
             <a:r>
-              <a:rPr lang="fr-FR" smtClean="0"/>
+              <a:rPr lang="fr-FR"/>
               <a:t>Cliquez pour modifier les styles du texte du masque</a:t>
             </a:r>
           </a:p>
           <a:p>
             <a:pPr lvl="1"/>
             <a:r>
-              <a:rPr lang="fr-FR" smtClean="0"/>
+              <a:rPr lang="fr-FR"/>
               <a:t>Deuxième niveau</a:t>
             </a:r>
           </a:p>
           <a:p>
             <a:pPr lvl="2"/>
             <a:r>
-              <a:rPr lang="fr-FR" smtClean="0"/>
+              <a:rPr lang="fr-FR"/>
               <a:t>Troisième niveau</a:t>
             </a:r>
           </a:p>
           <a:p>
             <a:pPr lvl="3"/>
             <a:r>
-              <a:rPr lang="fr-FR" smtClean="0"/>
+              <a:rPr lang="fr-FR"/>
               <a:t>Quatrième niveau</a:t>
             </a:r>
           </a:p>
           <a:p>
             <a:pPr lvl="4"/>
             <a:r>
-              <a:rPr lang="fr-FR" smtClean="0"/>
+              <a:rPr lang="fr-FR"/>
               <a:t>Cinquième niveau</a:t>
             </a:r>
             <a:endParaRPr lang="fr-BE"/>
@@ -807,7 +823,7 @@
             <a:fld id="{AA309A6D-C09C-4548-B29A-6CF363A7E532}" type="datetimeFigureOut">
               <a:rPr lang="fr-FR" smtClean="0"/>
               <a:pPr/>
-              <a:t>12/10/2014</a:t>
+              <a:t>02/08/2025</a:t>
             </a:fld>
             <a:endParaRPr lang="fr-BE"/>
           </a:p>
@@ -906,7 +922,7 @@
           </a:lstStyle>
           <a:p>
             <a:r>
-              <a:rPr lang="fr-FR" smtClean="0"/>
+              <a:rPr lang="fr-FR"/>
               <a:t>Cliquez pour modifier le style du titre</a:t>
             </a:r>
             <a:endParaRPr lang="fr-BE"/>
@@ -1026,7 +1042,7 @@
           <a:p>
             <a:pPr lvl="0"/>
             <a:r>
-              <a:rPr lang="fr-FR" smtClean="0"/>
+              <a:rPr lang="fr-FR"/>
               <a:t>Cliquez pour modifier les styles du texte du masque</a:t>
             </a:r>
           </a:p>
@@ -1050,7 +1066,7 @@
             <a:fld id="{AA309A6D-C09C-4548-B29A-6CF363A7E532}" type="datetimeFigureOut">
               <a:rPr lang="fr-FR" smtClean="0"/>
               <a:pPr/>
-              <a:t>12/10/2014</a:t>
+              <a:t>02/08/2025</a:t>
             </a:fld>
             <a:endParaRPr lang="fr-BE"/>
           </a:p>
@@ -1140,7 +1156,7 @@
           <a:lstStyle/>
           <a:p>
             <a:r>
-              <a:rPr lang="fr-FR" smtClean="0"/>
+              <a:rPr lang="fr-FR"/>
               <a:t>Cliquez pour modifier le style du titre</a:t>
             </a:r>
             <a:endParaRPr lang="fr-BE"/>
@@ -1197,35 +1213,35 @@
           <a:p>
             <a:pPr lvl="0"/>
             <a:r>
-              <a:rPr lang="fr-FR" smtClean="0"/>
+              <a:rPr lang="fr-FR"/>
               <a:t>Cliquez pour modifier les styles du texte du masque</a:t>
             </a:r>
           </a:p>
           <a:p>
             <a:pPr lvl="1"/>
             <a:r>
-              <a:rPr lang="fr-FR" smtClean="0"/>
+              <a:rPr lang="fr-FR"/>
               <a:t>Deuxième niveau</a:t>
             </a:r>
           </a:p>
           <a:p>
             <a:pPr lvl="2"/>
             <a:r>
-              <a:rPr lang="fr-FR" smtClean="0"/>
+              <a:rPr lang="fr-FR"/>
               <a:t>Troisième niveau</a:t>
             </a:r>
           </a:p>
           <a:p>
             <a:pPr lvl="3"/>
             <a:r>
-              <a:rPr lang="fr-FR" smtClean="0"/>
+              <a:rPr lang="fr-FR"/>
               <a:t>Quatrième niveau</a:t>
             </a:r>
           </a:p>
           <a:p>
             <a:pPr lvl="4"/>
             <a:r>
-              <a:rPr lang="fr-FR" smtClean="0"/>
+              <a:rPr lang="fr-FR"/>
               <a:t>Cinquième niveau</a:t>
             </a:r>
             <a:endParaRPr lang="fr-BE"/>
@@ -1282,35 +1298,35 @@
           <a:p>
             <a:pPr lvl="0"/>
             <a:r>
-              <a:rPr lang="fr-FR" smtClean="0"/>
+              <a:rPr lang="fr-FR"/>
               <a:t>Cliquez pour modifier les styles du texte du masque</a:t>
             </a:r>
           </a:p>
           <a:p>
             <a:pPr lvl="1"/>
             <a:r>
-              <a:rPr lang="fr-FR" smtClean="0"/>
+              <a:rPr lang="fr-FR"/>
               <a:t>Deuxième niveau</a:t>
             </a:r>
           </a:p>
           <a:p>
             <a:pPr lvl="2"/>
             <a:r>
-              <a:rPr lang="fr-FR" smtClean="0"/>
+              <a:rPr lang="fr-FR"/>
               <a:t>Troisième niveau</a:t>
             </a:r>
           </a:p>
           <a:p>
             <a:pPr lvl="3"/>
             <a:r>
-              <a:rPr lang="fr-FR" smtClean="0"/>
+              <a:rPr lang="fr-FR"/>
               <a:t>Quatrième niveau</a:t>
             </a:r>
           </a:p>
           <a:p>
             <a:pPr lvl="4"/>
             <a:r>
-              <a:rPr lang="fr-FR" smtClean="0"/>
+              <a:rPr lang="fr-FR"/>
               <a:t>Cinquième niveau</a:t>
             </a:r>
             <a:endParaRPr lang="fr-BE"/>
@@ -1335,7 +1351,7 @@
             <a:fld id="{AA309A6D-C09C-4548-B29A-6CF363A7E532}" type="datetimeFigureOut">
               <a:rPr lang="fr-FR" smtClean="0"/>
               <a:pPr/>
-              <a:t>12/10/2014</a:t>
+              <a:t>02/08/2025</a:t>
             </a:fld>
             <a:endParaRPr lang="fr-BE"/>
           </a:p>
@@ -1429,7 +1445,7 @@
           </a:lstStyle>
           <a:p>
             <a:r>
-              <a:rPr lang="fr-FR" smtClean="0"/>
+              <a:rPr lang="fr-FR"/>
               <a:t>Cliquez pour modifier le style du titre</a:t>
             </a:r>
             <a:endParaRPr lang="fr-BE"/>
@@ -1495,7 +1511,7 @@
           <a:p>
             <a:pPr lvl="0"/>
             <a:r>
-              <a:rPr lang="fr-FR" smtClean="0"/>
+              <a:rPr lang="fr-FR"/>
               <a:t>Cliquez pour modifier les styles du texte du masque</a:t>
             </a:r>
           </a:p>
@@ -1551,35 +1567,35 @@
           <a:p>
             <a:pPr lvl="0"/>
             <a:r>
-              <a:rPr lang="fr-FR" smtClean="0"/>
+              <a:rPr lang="fr-FR"/>
               <a:t>Cliquez pour modifier les styles du texte du masque</a:t>
             </a:r>
           </a:p>
           <a:p>
             <a:pPr lvl="1"/>
             <a:r>
-              <a:rPr lang="fr-FR" smtClean="0"/>
+              <a:rPr lang="fr-FR"/>
               <a:t>Deuxième niveau</a:t>
             </a:r>
           </a:p>
           <a:p>
             <a:pPr lvl="2"/>
             <a:r>
-              <a:rPr lang="fr-FR" smtClean="0"/>
+              <a:rPr lang="fr-FR"/>
               <a:t>Troisième niveau</a:t>
             </a:r>
           </a:p>
           <a:p>
             <a:pPr lvl="3"/>
             <a:r>
-              <a:rPr lang="fr-FR" smtClean="0"/>
+              <a:rPr lang="fr-FR"/>
               <a:t>Quatrième niveau</a:t>
             </a:r>
           </a:p>
           <a:p>
             <a:pPr lvl="4"/>
             <a:r>
-              <a:rPr lang="fr-FR" smtClean="0"/>
+              <a:rPr lang="fr-FR"/>
               <a:t>Cinquième niveau</a:t>
             </a:r>
             <a:endParaRPr lang="fr-BE"/>
@@ -1645,7 +1661,7 @@
           <a:p>
             <a:pPr lvl="0"/>
             <a:r>
-              <a:rPr lang="fr-FR" smtClean="0"/>
+              <a:rPr lang="fr-FR"/>
               <a:t>Cliquez pour modifier les styles du texte du masque</a:t>
             </a:r>
           </a:p>
@@ -1701,35 +1717,35 @@
           <a:p>
             <a:pPr lvl="0"/>
             <a:r>
-              <a:rPr lang="fr-FR" smtClean="0"/>
+              <a:rPr lang="fr-FR"/>
               <a:t>Cliquez pour modifier les styles du texte du masque</a:t>
             </a:r>
           </a:p>
           <a:p>
             <a:pPr lvl="1"/>
             <a:r>
-              <a:rPr lang="fr-FR" smtClean="0"/>
+              <a:rPr lang="fr-FR"/>
               <a:t>Deuxième niveau</a:t>
             </a:r>
           </a:p>
           <a:p>
             <a:pPr lvl="2"/>
             <a:r>
-              <a:rPr lang="fr-FR" smtClean="0"/>
+              <a:rPr lang="fr-FR"/>
               <a:t>Troisième niveau</a:t>
             </a:r>
           </a:p>
           <a:p>
             <a:pPr lvl="3"/>
             <a:r>
-              <a:rPr lang="fr-FR" smtClean="0"/>
+              <a:rPr lang="fr-FR"/>
               <a:t>Quatrième niveau</a:t>
             </a:r>
           </a:p>
           <a:p>
             <a:pPr lvl="4"/>
             <a:r>
-              <a:rPr lang="fr-FR" smtClean="0"/>
+              <a:rPr lang="fr-FR"/>
               <a:t>Cinquième niveau</a:t>
             </a:r>
             <a:endParaRPr lang="fr-BE"/>
@@ -1754,7 +1770,7 @@
             <a:fld id="{AA309A6D-C09C-4548-B29A-6CF363A7E532}" type="datetimeFigureOut">
               <a:rPr lang="fr-FR" smtClean="0"/>
               <a:pPr/>
-              <a:t>12/10/2014</a:t>
+              <a:t>02/08/2025</a:t>
             </a:fld>
             <a:endParaRPr lang="fr-BE"/>
           </a:p>
@@ -1844,7 +1860,7 @@
           <a:lstStyle/>
           <a:p>
             <a:r>
-              <a:rPr lang="fr-FR" smtClean="0"/>
+              <a:rPr lang="fr-FR"/>
               <a:t>Cliquez pour modifier le style du titre</a:t>
             </a:r>
             <a:endParaRPr lang="fr-BE"/>
@@ -1869,7 +1885,7 @@
             <a:fld id="{AA309A6D-C09C-4548-B29A-6CF363A7E532}" type="datetimeFigureOut">
               <a:rPr lang="fr-FR" smtClean="0"/>
               <a:pPr/>
-              <a:t>12/10/2014</a:t>
+              <a:t>02/08/2025</a:t>
             </a:fld>
             <a:endParaRPr lang="fr-BE"/>
           </a:p>
@@ -1961,7 +1977,7 @@
             <a:fld id="{AA309A6D-C09C-4548-B29A-6CF363A7E532}" type="datetimeFigureOut">
               <a:rPr lang="fr-FR" smtClean="0"/>
               <a:pPr/>
-              <a:t>12/10/2014</a:t>
+              <a:t>02/08/2025</a:t>
             </a:fld>
             <a:endParaRPr lang="fr-BE"/>
           </a:p>
@@ -2060,7 +2076,7 @@
           </a:lstStyle>
           <a:p>
             <a:r>
-              <a:rPr lang="fr-FR" smtClean="0"/>
+              <a:rPr lang="fr-FR"/>
               <a:t>Cliquez pour modifier le style du titre</a:t>
             </a:r>
             <a:endParaRPr lang="fr-BE"/>
@@ -2117,35 +2133,35 @@
           <a:p>
             <a:pPr lvl="0"/>
             <a:r>
-              <a:rPr lang="fr-FR" smtClean="0"/>
+              <a:rPr lang="fr-FR"/>
               <a:t>Cliquez pour modifier les styles du texte du masque</a:t>
             </a:r>
           </a:p>
           <a:p>
             <a:pPr lvl="1"/>
             <a:r>
-              <a:rPr lang="fr-FR" smtClean="0"/>
+              <a:rPr lang="fr-FR"/>
               <a:t>Deuxième niveau</a:t>
             </a:r>
           </a:p>
           <a:p>
             <a:pPr lvl="2"/>
             <a:r>
-              <a:rPr lang="fr-FR" smtClean="0"/>
+              <a:rPr lang="fr-FR"/>
               <a:t>Troisième niveau</a:t>
             </a:r>
           </a:p>
           <a:p>
             <a:pPr lvl="3"/>
             <a:r>
-              <a:rPr lang="fr-FR" smtClean="0"/>
+              <a:rPr lang="fr-FR"/>
               <a:t>Quatrième niveau</a:t>
             </a:r>
           </a:p>
           <a:p>
             <a:pPr lvl="4"/>
             <a:r>
-              <a:rPr lang="fr-FR" smtClean="0"/>
+              <a:rPr lang="fr-FR"/>
               <a:t>Cinquième niveau</a:t>
             </a:r>
             <a:endParaRPr lang="fr-BE"/>
@@ -2211,7 +2227,7 @@
           <a:p>
             <a:pPr lvl="0"/>
             <a:r>
-              <a:rPr lang="fr-FR" smtClean="0"/>
+              <a:rPr lang="fr-FR"/>
               <a:t>Cliquez pour modifier les styles du texte du masque</a:t>
             </a:r>
           </a:p>
@@ -2235,7 +2251,7 @@
             <a:fld id="{AA309A6D-C09C-4548-B29A-6CF363A7E532}" type="datetimeFigureOut">
               <a:rPr lang="fr-FR" smtClean="0"/>
               <a:pPr/>
-              <a:t>12/10/2014</a:t>
+              <a:t>02/08/2025</a:t>
             </a:fld>
             <a:endParaRPr lang="fr-BE"/>
           </a:p>
@@ -2334,7 +2350,7 @@
           </a:lstStyle>
           <a:p>
             <a:r>
-              <a:rPr lang="fr-FR" smtClean="0"/>
+              <a:rPr lang="fr-FR"/>
               <a:t>Cliquez pour modifier le style du titre</a:t>
             </a:r>
             <a:endParaRPr lang="fr-BE"/>
@@ -2461,7 +2477,7 @@
           <a:p>
             <a:pPr lvl="0"/>
             <a:r>
-              <a:rPr lang="fr-FR" smtClean="0"/>
+              <a:rPr lang="fr-FR"/>
               <a:t>Cliquez pour modifier les styles du texte du masque</a:t>
             </a:r>
           </a:p>
@@ -2485,7 +2501,7 @@
             <a:fld id="{AA309A6D-C09C-4548-B29A-6CF363A7E532}" type="datetimeFigureOut">
               <a:rPr lang="fr-FR" smtClean="0"/>
               <a:pPr/>
-              <a:t>12/10/2014</a:t>
+              <a:t>02/08/2025</a:t>
             </a:fld>
             <a:endParaRPr lang="fr-BE"/>
           </a:p>
@@ -2590,7 +2606,7 @@
           <a:lstStyle/>
           <a:p>
             <a:r>
-              <a:rPr lang="fr-FR" smtClean="0"/>
+              <a:rPr lang="fr-FR"/>
               <a:t>Cliquez pour modifier le style du titre</a:t>
             </a:r>
             <a:endParaRPr lang="fr-BE"/>
@@ -2624,35 +2640,35 @@
           <a:p>
             <a:pPr lvl="0"/>
             <a:r>
-              <a:rPr lang="fr-FR" smtClean="0"/>
+              <a:rPr lang="fr-FR"/>
               <a:t>Cliquez pour modifier les styles du texte du masque</a:t>
             </a:r>
           </a:p>
           <a:p>
             <a:pPr lvl="1"/>
             <a:r>
-              <a:rPr lang="fr-FR" smtClean="0"/>
+              <a:rPr lang="fr-FR"/>
               <a:t>Deuxième niveau</a:t>
             </a:r>
           </a:p>
           <a:p>
             <a:pPr lvl="2"/>
             <a:r>
-              <a:rPr lang="fr-FR" smtClean="0"/>
+              <a:rPr lang="fr-FR"/>
               <a:t>Troisième niveau</a:t>
             </a:r>
           </a:p>
           <a:p>
             <a:pPr lvl="3"/>
             <a:r>
-              <a:rPr lang="fr-FR" smtClean="0"/>
+              <a:rPr lang="fr-FR"/>
               <a:t>Quatrième niveau</a:t>
             </a:r>
           </a:p>
           <a:p>
             <a:pPr lvl="4"/>
             <a:r>
-              <a:rPr lang="fr-FR" smtClean="0"/>
+              <a:rPr lang="fr-FR"/>
               <a:t>Cinquième niveau</a:t>
             </a:r>
             <a:endParaRPr lang="fr-BE"/>
@@ -2695,7 +2711,7 @@
             <a:fld id="{AA309A6D-C09C-4548-B29A-6CF363A7E532}" type="datetimeFigureOut">
               <a:rPr lang="fr-FR" smtClean="0"/>
               <a:pPr/>
-              <a:t>12/10/2014</a:t>
+              <a:t>02/08/2025</a:t>
             </a:fld>
             <a:endParaRPr lang="fr-BE"/>
           </a:p>
@@ -3084,24 +3100,16 @@
         </p:spPr>
         <p:txBody>
           <a:bodyPr>
-            <a:normAutofit fontScale="90000"/>
+            <a:normAutofit/>
           </a:bodyPr>
           <a:lstStyle/>
           <a:p>
             <a:r>
-              <a:rPr lang="fr-FR" dirty="0" smtClean="0">
+              <a:rPr lang="fr-FR" dirty="0">
                 <a:latin typeface="Cambria" pitchFamily="18" charset="0"/>
               </a:rPr>
               <a:t>HIRA 295</a:t>
             </a:r>
-            <a:br>
-              <a:rPr lang="fr-FR" dirty="0" smtClean="0">
-                <a:latin typeface="Cambria" pitchFamily="18" charset="0"/>
-              </a:rPr>
-            </a:br>
-            <a:endParaRPr lang="fr-FR" dirty="0">
-              <a:latin typeface="Cambria" pitchFamily="18" charset="0"/>
-            </a:endParaRPr>
           </a:p>
         </p:txBody>
       </p:sp>
@@ -3131,42 +3139,42 @@
               <a:buNone/>
             </a:pPr>
             <a:r>
-              <a:rPr lang="en-US" sz="6600" b="1" dirty="0" smtClean="0">
+              <a:rPr lang="en-US" sz="6600" b="1" dirty="0">
                 <a:latin typeface="Cambria" pitchFamily="18" charset="0"/>
               </a:rPr>
               <a:t>1. </a:t>
             </a:r>
             <a:r>
-              <a:rPr lang="en-US" sz="6600" b="1" dirty="0" err="1" smtClean="0">
+              <a:rPr lang="en-US" sz="6600" b="1" dirty="0" err="1">
                 <a:latin typeface="Cambria" pitchFamily="18" charset="0"/>
               </a:rPr>
               <a:t>Miorena</a:t>
             </a:r>
             <a:r>
-              <a:rPr lang="en-US" sz="6600" b="1" dirty="0" smtClean="0">
+              <a:rPr lang="en-US" sz="6600" b="1" dirty="0">
                 <a:latin typeface="Cambria" pitchFamily="18" charset="0"/>
               </a:rPr>
               <a:t> </a:t>
             </a:r>
             <a:r>
-              <a:rPr lang="en-US" sz="6600" b="1" dirty="0" err="1" smtClean="0">
+              <a:rPr lang="en-US" sz="6600" b="1" dirty="0" err="1">
                 <a:latin typeface="Cambria" pitchFamily="18" charset="0"/>
               </a:rPr>
               <a:t>mafy</a:t>
             </a:r>
             <a:r>
-              <a:rPr lang="en-US" sz="6600" b="1" dirty="0" smtClean="0">
+              <a:rPr lang="en-US" sz="6600" b="1" dirty="0">
                 <a:latin typeface="Cambria" pitchFamily="18" charset="0"/>
               </a:rPr>
               <a:t> </a:t>
             </a:r>
             <a:r>
-              <a:rPr lang="en-US" sz="6600" b="1" dirty="0" err="1" smtClean="0">
+              <a:rPr lang="en-US" sz="6600" b="1" dirty="0" err="1">
                 <a:latin typeface="Cambria" pitchFamily="18" charset="0"/>
               </a:rPr>
               <a:t>tsara</a:t>
             </a:r>
-            <a:endParaRPr lang="fr-FR" sz="6600" b="1" dirty="0" smtClean="0">
+            <a:endParaRPr lang="fr-FR" sz="6600" b="1" dirty="0">
               <a:latin typeface="Cambria" pitchFamily="18" charset="0"/>
             </a:endParaRPr>
           </a:p>
@@ -3175,24 +3183,24 @@
               <a:buNone/>
             </a:pPr>
             <a:r>
-              <a:rPr lang="en-US" sz="6600" b="1" dirty="0" err="1" smtClean="0">
+              <a:rPr lang="en-US" sz="6600" b="1" dirty="0" err="1">
                 <a:latin typeface="Cambria" pitchFamily="18" charset="0"/>
               </a:rPr>
               <a:t>Amin'Ilay</a:t>
             </a:r>
             <a:r>
-              <a:rPr lang="en-US" sz="6600" b="1" dirty="0" smtClean="0">
+              <a:rPr lang="en-US" sz="6600" b="1" dirty="0">
                 <a:latin typeface="Cambria" pitchFamily="18" charset="0"/>
               </a:rPr>
               <a:t> </a:t>
             </a:r>
             <a:r>
-              <a:rPr lang="en-US" sz="6600" b="1" dirty="0" err="1" smtClean="0">
+              <a:rPr lang="en-US" sz="6600" b="1" dirty="0" err="1">
                 <a:latin typeface="Cambria" pitchFamily="18" charset="0"/>
               </a:rPr>
               <a:t>vatosoa</a:t>
             </a:r>
-            <a:endParaRPr lang="fr-FR" sz="6600" b="1" dirty="0" smtClean="0">
+            <a:endParaRPr lang="fr-FR" sz="6600" b="1" dirty="0">
               <a:latin typeface="Cambria" pitchFamily="18" charset="0"/>
             </a:endParaRPr>
           </a:p>
@@ -3201,30 +3209,30 @@
               <a:buNone/>
             </a:pPr>
             <a:r>
-              <a:rPr lang="en-US" sz="6600" b="1" dirty="0" err="1" smtClean="0">
+              <a:rPr lang="en-US" sz="6600" b="1" dirty="0" err="1">
                 <a:latin typeface="Cambria" pitchFamily="18" charset="0"/>
               </a:rPr>
               <a:t>Mandrosoa</a:t>
             </a:r>
             <a:r>
-              <a:rPr lang="en-US" sz="6600" b="1" dirty="0" smtClean="0">
+              <a:rPr lang="en-US" sz="6600" b="1" dirty="0">
                 <a:latin typeface="Cambria" pitchFamily="18" charset="0"/>
               </a:rPr>
               <a:t>, </a:t>
             </a:r>
             <a:r>
-              <a:rPr lang="en-US" sz="6600" b="1" dirty="0" err="1" smtClean="0">
+              <a:rPr lang="en-US" sz="6600" b="1" dirty="0" err="1">
                 <a:latin typeface="Cambria" pitchFamily="18" charset="0"/>
               </a:rPr>
               <a:t>mifahara</a:t>
             </a:r>
             <a:r>
-              <a:rPr lang="en-US" sz="6600" b="1" dirty="0" smtClean="0">
+              <a:rPr lang="en-US" sz="6600" b="1" dirty="0">
                 <a:latin typeface="Cambria" pitchFamily="18" charset="0"/>
               </a:rPr>
               <a:t>,</a:t>
             </a:r>
-            <a:endParaRPr lang="fr-FR" sz="6600" b="1" dirty="0" smtClean="0">
+            <a:endParaRPr lang="fr-FR" sz="6600" b="1" dirty="0">
               <a:latin typeface="Cambria" pitchFamily="18" charset="0"/>
             </a:endParaRPr>
           </a:p>
@@ -3233,42 +3241,42 @@
               <a:buNone/>
             </a:pPr>
             <a:r>
-              <a:rPr lang="en-US" sz="6600" b="1" dirty="0" err="1" smtClean="0">
+              <a:rPr lang="en-US" sz="6600" b="1" dirty="0" err="1">
                 <a:latin typeface="Cambria" pitchFamily="18" charset="0"/>
               </a:rPr>
               <a:t>Mifikira</a:t>
             </a:r>
             <a:r>
-              <a:rPr lang="en-US" sz="6600" b="1" dirty="0" smtClean="0">
+              <a:rPr lang="en-US" sz="6600" b="1" dirty="0">
                 <a:latin typeface="Cambria" pitchFamily="18" charset="0"/>
               </a:rPr>
               <a:t> </a:t>
             </a:r>
             <a:r>
-              <a:rPr lang="en-US" sz="6600" b="1" dirty="0" err="1" smtClean="0">
+              <a:rPr lang="en-US" sz="6600" b="1" dirty="0" err="1">
                 <a:latin typeface="Cambria" pitchFamily="18" charset="0"/>
               </a:rPr>
               <a:t>mafy</a:t>
             </a:r>
             <a:r>
-              <a:rPr lang="en-US" sz="6600" b="1" dirty="0" smtClean="0">
+              <a:rPr lang="en-US" sz="6600" b="1" dirty="0">
                 <a:latin typeface="Cambria" pitchFamily="18" charset="0"/>
               </a:rPr>
               <a:t> </a:t>
             </a:r>
             <a:r>
-              <a:rPr lang="en-US" sz="6600" b="1" dirty="0" err="1" smtClean="0">
+              <a:rPr lang="en-US" sz="6600" b="1" dirty="0" err="1">
                 <a:latin typeface="Cambria" pitchFamily="18" charset="0"/>
               </a:rPr>
               <a:t>koa</a:t>
             </a:r>
             <a:r>
-              <a:rPr lang="en-US" sz="6600" b="1" dirty="0" smtClean="0">
+              <a:rPr lang="en-US" sz="6600" b="1" dirty="0">
                 <a:latin typeface="Cambria" pitchFamily="18" charset="0"/>
               </a:rPr>
               <a:t>.</a:t>
             </a:r>
-            <a:endParaRPr lang="fr-FR" sz="6600" b="1" dirty="0" smtClean="0">
+            <a:endParaRPr lang="fr-FR" sz="6600" b="1" dirty="0">
               <a:latin typeface="Cambria" pitchFamily="18" charset="0"/>
             </a:endParaRPr>
           </a:p>
@@ -3287,13 +3295,6 @@
   <p:clrMapOvr>
     <a:masterClrMapping/>
   </p:clrMapOvr>
-  <p:timing>
-    <p:tnLst>
-      <p:par>
-        <p:cTn id="1" dur="indefinite" restart="never" nodeType="tmRoot"/>
-      </p:par>
-    </p:tnLst>
-  </p:timing>
 </p:sld>
 </file>
 
@@ -3332,24 +3333,16 @@
         </p:spPr>
         <p:txBody>
           <a:bodyPr>
-            <a:normAutofit fontScale="90000"/>
+            <a:normAutofit/>
           </a:bodyPr>
           <a:lstStyle/>
           <a:p>
             <a:r>
-              <a:rPr lang="fr-FR" dirty="0" smtClean="0">
+              <a:rPr lang="fr-FR" dirty="0">
                 <a:latin typeface="Cambria" pitchFamily="18" charset="0"/>
               </a:rPr>
               <a:t>HIRA 295</a:t>
             </a:r>
-            <a:br>
-              <a:rPr lang="fr-FR" dirty="0" smtClean="0">
-                <a:latin typeface="Cambria" pitchFamily="18" charset="0"/>
-              </a:rPr>
-            </a:br>
-            <a:endParaRPr lang="fr-FR" dirty="0">
-              <a:latin typeface="Cambria" pitchFamily="18" charset="0"/>
-            </a:endParaRPr>
           </a:p>
         </p:txBody>
       </p:sp>
@@ -3379,42 +3372,42 @@
               <a:buNone/>
             </a:pPr>
             <a:r>
-              <a:rPr lang="fr-FR" sz="6600" b="1" dirty="0" smtClean="0">
+              <a:rPr lang="fr-FR" sz="6600" b="1" dirty="0">
                 <a:latin typeface="Cambria" pitchFamily="18" charset="0"/>
               </a:rPr>
               <a:t>He! </a:t>
             </a:r>
             <a:r>
-              <a:rPr lang="fr-FR" sz="6600" b="1" dirty="0" err="1" smtClean="0">
+              <a:rPr lang="fr-FR" sz="6600" b="1" dirty="0" err="1">
                 <a:latin typeface="Cambria" pitchFamily="18" charset="0"/>
               </a:rPr>
               <a:t>Ny</a:t>
             </a:r>
             <a:r>
-              <a:rPr lang="fr-FR" sz="6600" b="1" dirty="0" smtClean="0">
+              <a:rPr lang="fr-FR" sz="6600" b="1" dirty="0">
                 <a:latin typeface="Cambria" pitchFamily="18" charset="0"/>
               </a:rPr>
               <a:t> </a:t>
             </a:r>
             <a:r>
-              <a:rPr lang="fr-FR" sz="6600" b="1" dirty="0" err="1" smtClean="0">
+              <a:rPr lang="fr-FR" sz="6600" b="1" dirty="0" err="1">
                 <a:latin typeface="Cambria" pitchFamily="18" charset="0"/>
               </a:rPr>
               <a:t>Tompo</a:t>
             </a:r>
             <a:r>
-              <a:rPr lang="fr-FR" sz="6600" b="1" dirty="0" smtClean="0">
+              <a:rPr lang="fr-FR" sz="6600" b="1" dirty="0">
                 <a:latin typeface="Cambria" pitchFamily="18" charset="0"/>
               </a:rPr>
               <a:t> </a:t>
             </a:r>
             <a:r>
-              <a:rPr lang="fr-FR" sz="6600" b="1" dirty="0" err="1" smtClean="0">
+              <a:rPr lang="fr-FR" sz="6600" b="1" dirty="0" err="1">
                 <a:latin typeface="Cambria" pitchFamily="18" charset="0"/>
               </a:rPr>
               <a:t>manambara</a:t>
             </a:r>
-            <a:endParaRPr lang="fr-FR" sz="6600" b="1" dirty="0" smtClean="0">
+            <a:endParaRPr lang="fr-FR" sz="6600" b="1" dirty="0">
               <a:latin typeface="Cambria" pitchFamily="18" charset="0"/>
             </a:endParaRPr>
           </a:p>
@@ -3423,31 +3416,31 @@
               <a:buNone/>
             </a:pPr>
             <a:r>
-              <a:rPr lang="fr-FR" sz="6600" b="1" dirty="0" smtClean="0">
+              <a:rPr lang="fr-FR" sz="6600" b="1" dirty="0">
                 <a:latin typeface="Cambria" pitchFamily="18" charset="0"/>
               </a:rPr>
               <a:t>Fa ho </a:t>
             </a:r>
             <a:r>
-              <a:rPr lang="fr-FR" sz="6600" b="1" dirty="0" err="1" smtClean="0">
+              <a:rPr lang="fr-FR" sz="6600" b="1" dirty="0" err="1">
                 <a:latin typeface="Cambria" pitchFamily="18" charset="0"/>
               </a:rPr>
               <a:t>sambatra</a:t>
             </a:r>
             <a:r>
-              <a:rPr lang="fr-FR" sz="6600" b="1" dirty="0" smtClean="0">
+              <a:rPr lang="fr-FR" sz="6600" b="1" dirty="0">
                 <a:latin typeface="Cambria" pitchFamily="18" charset="0"/>
               </a:rPr>
               <a:t> </a:t>
             </a:r>
             <a:r>
-              <a:rPr lang="fr-FR" sz="6600" b="1" dirty="0" err="1" smtClean="0">
+              <a:rPr lang="fr-FR" sz="6600" b="1" dirty="0" err="1">
                 <a:latin typeface="Cambria" pitchFamily="18" charset="0"/>
               </a:rPr>
               <a:t>tokoa</a:t>
             </a:r>
             <a:r>
-              <a:rPr lang="fr-FR" sz="6600" b="1" dirty="0" smtClean="0">
+              <a:rPr lang="fr-FR" sz="6600" b="1" dirty="0">
                 <a:latin typeface="Cambria" pitchFamily="18" charset="0"/>
               </a:rPr>
               <a:t>,</a:t>
@@ -3458,30 +3451,30 @@
               <a:buNone/>
             </a:pPr>
             <a:r>
-              <a:rPr lang="fr-FR" sz="6600" b="1" dirty="0" smtClean="0">
+              <a:rPr lang="fr-FR" sz="6600" b="1" dirty="0">
                 <a:latin typeface="Cambria" pitchFamily="18" charset="0"/>
               </a:rPr>
               <a:t>Ka ho </a:t>
             </a:r>
             <a:r>
-              <a:rPr lang="fr-FR" sz="6600" b="1" dirty="0" err="1" smtClean="0">
+              <a:rPr lang="fr-FR" sz="6600" b="1" dirty="0" err="1">
                 <a:latin typeface="Cambria" pitchFamily="18" charset="0"/>
               </a:rPr>
               <a:t>tsara</a:t>
             </a:r>
             <a:r>
-              <a:rPr lang="fr-FR" sz="6600" b="1" dirty="0" smtClean="0">
+              <a:rPr lang="fr-FR" sz="6600" b="1" dirty="0">
                 <a:latin typeface="Cambria" pitchFamily="18" charset="0"/>
               </a:rPr>
               <a:t> </a:t>
             </a:r>
             <a:r>
-              <a:rPr lang="fr-FR" sz="6600" b="1" dirty="0" err="1" smtClean="0">
+              <a:rPr lang="fr-FR" sz="6600" b="1" dirty="0" err="1">
                 <a:latin typeface="Cambria" pitchFamily="18" charset="0"/>
               </a:rPr>
               <a:t>miafara</a:t>
             </a:r>
-            <a:endParaRPr lang="fr-FR" sz="6600" b="1" dirty="0" smtClean="0">
+            <a:endParaRPr lang="fr-FR" sz="6600" b="1" dirty="0">
               <a:latin typeface="Cambria" pitchFamily="18" charset="0"/>
             </a:endParaRPr>
           </a:p>
@@ -3490,37 +3483,37 @@
               <a:buNone/>
             </a:pPr>
             <a:r>
-              <a:rPr lang="fr-FR" sz="6600" b="1" dirty="0" err="1" smtClean="0">
+              <a:rPr lang="fr-FR" sz="6600" b="1" dirty="0" err="1">
                 <a:latin typeface="Cambria" pitchFamily="18" charset="0"/>
               </a:rPr>
               <a:t>Ny</a:t>
             </a:r>
             <a:r>
-              <a:rPr lang="fr-FR" sz="6600" b="1" dirty="0" smtClean="0">
+              <a:rPr lang="fr-FR" sz="6600" b="1" dirty="0">
                 <a:latin typeface="Cambria" pitchFamily="18" charset="0"/>
               </a:rPr>
               <a:t> </a:t>
             </a:r>
             <a:r>
-              <a:rPr lang="fr-FR" sz="6600" b="1" dirty="0" err="1" smtClean="0">
+              <a:rPr lang="fr-FR" sz="6600" b="1" dirty="0" err="1">
                 <a:latin typeface="Cambria" pitchFamily="18" charset="0"/>
               </a:rPr>
               <a:t>mpanompo</a:t>
             </a:r>
             <a:r>
-              <a:rPr lang="fr-FR" sz="6600" b="1" dirty="0" smtClean="0">
+              <a:rPr lang="fr-FR" sz="6600" b="1" dirty="0">
                 <a:latin typeface="Cambria" pitchFamily="18" charset="0"/>
               </a:rPr>
               <a:t> </a:t>
             </a:r>
             <a:r>
-              <a:rPr lang="fr-FR" sz="6600" b="1" dirty="0" err="1" smtClean="0">
+              <a:rPr lang="fr-FR" sz="6600" b="1" dirty="0" err="1">
                 <a:latin typeface="Cambria" pitchFamily="18" charset="0"/>
               </a:rPr>
               <a:t>mahasoa</a:t>
             </a:r>
             <a:r>
-              <a:rPr lang="fr-FR" sz="6600" b="1" dirty="0" smtClean="0">
+              <a:rPr lang="fr-FR" sz="6600" b="1" dirty="0">
                 <a:latin typeface="Cambria" pitchFamily="18" charset="0"/>
               </a:rPr>
               <a:t>.</a:t>
@@ -3541,13 +3534,6 @@
   <p:clrMapOvr>
     <a:masterClrMapping/>
   </p:clrMapOvr>
-  <p:timing>
-    <p:tnLst>
-      <p:par>
-        <p:cTn id="1" dur="indefinite" restart="never" nodeType="tmRoot"/>
-      </p:par>
-    </p:tnLst>
-  </p:timing>
 </p:sld>
 </file>
 
@@ -3586,24 +3572,16 @@
         </p:spPr>
         <p:txBody>
           <a:bodyPr>
-            <a:normAutofit fontScale="90000"/>
+            <a:normAutofit/>
           </a:bodyPr>
           <a:lstStyle/>
           <a:p>
             <a:r>
-              <a:rPr lang="fr-FR" dirty="0" smtClean="0">
+              <a:rPr lang="fr-FR" dirty="0">
                 <a:latin typeface="Cambria" pitchFamily="18" charset="0"/>
               </a:rPr>
               <a:t>HIRA 295</a:t>
             </a:r>
-            <a:br>
-              <a:rPr lang="fr-FR" dirty="0" smtClean="0">
-                <a:latin typeface="Cambria" pitchFamily="18" charset="0"/>
-              </a:rPr>
-            </a:br>
-            <a:endParaRPr lang="fr-FR" dirty="0">
-              <a:latin typeface="Cambria" pitchFamily="18" charset="0"/>
-            </a:endParaRPr>
           </a:p>
         </p:txBody>
       </p:sp>
@@ -3633,42 +3611,42 @@
               <a:buNone/>
             </a:pPr>
             <a:r>
-              <a:rPr lang="fr-FR" sz="6600" b="1" dirty="0" smtClean="0">
+              <a:rPr lang="fr-FR" sz="6600" b="1" dirty="0">
                 <a:latin typeface="Cambria" pitchFamily="18" charset="0"/>
               </a:rPr>
               <a:t>2. </a:t>
             </a:r>
             <a:r>
-              <a:rPr lang="fr-FR" sz="6600" b="1" dirty="0" err="1" smtClean="0">
+              <a:rPr lang="fr-FR" sz="6600" b="1" dirty="0" err="1">
                 <a:latin typeface="Cambria" pitchFamily="18" charset="0"/>
               </a:rPr>
               <a:t>Raha</a:t>
             </a:r>
             <a:r>
-              <a:rPr lang="fr-FR" sz="6600" b="1" dirty="0" smtClean="0">
+              <a:rPr lang="fr-FR" sz="6600" b="1" dirty="0">
                 <a:latin typeface="Cambria" pitchFamily="18" charset="0"/>
               </a:rPr>
               <a:t> </a:t>
             </a:r>
             <a:r>
-              <a:rPr lang="fr-FR" sz="6600" b="1" dirty="0" err="1" smtClean="0">
+              <a:rPr lang="fr-FR" sz="6600" b="1" dirty="0" err="1">
                 <a:latin typeface="Cambria" pitchFamily="18" charset="0"/>
               </a:rPr>
               <a:t>misy</a:t>
             </a:r>
             <a:r>
-              <a:rPr lang="fr-FR" sz="6600" b="1" dirty="0" smtClean="0">
+              <a:rPr lang="fr-FR" sz="6600" b="1" dirty="0">
                 <a:latin typeface="Cambria" pitchFamily="18" charset="0"/>
               </a:rPr>
               <a:t> </a:t>
             </a:r>
             <a:r>
-              <a:rPr lang="fr-FR" sz="6600" b="1" dirty="0" err="1" smtClean="0">
+              <a:rPr lang="fr-FR" sz="6600" b="1" dirty="0" err="1">
                 <a:latin typeface="Cambria" pitchFamily="18" charset="0"/>
               </a:rPr>
               <a:t>fahoriana</a:t>
             </a:r>
-            <a:endParaRPr lang="fr-FR" sz="6600" b="1" dirty="0" smtClean="0">
+            <a:endParaRPr lang="fr-FR" sz="6600" b="1" dirty="0">
               <a:latin typeface="Cambria" pitchFamily="18" charset="0"/>
             </a:endParaRPr>
           </a:p>
@@ -3677,31 +3655,31 @@
               <a:buNone/>
             </a:pPr>
             <a:r>
-              <a:rPr lang="fr-FR" sz="6600" b="1" dirty="0" smtClean="0">
+              <a:rPr lang="fr-FR" sz="6600" b="1" dirty="0">
                 <a:latin typeface="Cambria" pitchFamily="18" charset="0"/>
               </a:rPr>
               <a:t>'Zay </a:t>
             </a:r>
             <a:r>
-              <a:rPr lang="fr-FR" sz="6600" b="1" dirty="0" err="1" smtClean="0">
+              <a:rPr lang="fr-FR" sz="6600" b="1" dirty="0" err="1">
                 <a:latin typeface="Cambria" pitchFamily="18" charset="0"/>
               </a:rPr>
               <a:t>midona</a:t>
             </a:r>
             <a:r>
-              <a:rPr lang="fr-FR" sz="6600" b="1" dirty="0" smtClean="0">
+              <a:rPr lang="fr-FR" sz="6600" b="1" dirty="0">
                 <a:latin typeface="Cambria" pitchFamily="18" charset="0"/>
               </a:rPr>
               <a:t> </a:t>
             </a:r>
             <a:r>
-              <a:rPr lang="fr-FR" sz="6600" b="1" dirty="0" err="1" smtClean="0">
+              <a:rPr lang="fr-FR" sz="6600" b="1" dirty="0" err="1">
                 <a:latin typeface="Cambria" pitchFamily="18" charset="0"/>
               </a:rPr>
               <a:t>aminao</a:t>
             </a:r>
             <a:r>
-              <a:rPr lang="fr-FR" sz="6600" b="1" dirty="0" smtClean="0">
+              <a:rPr lang="fr-FR" sz="6600" b="1" dirty="0">
                 <a:latin typeface="Cambria" pitchFamily="18" charset="0"/>
               </a:rPr>
               <a:t>,</a:t>
@@ -3712,36 +3690,36 @@
               <a:buNone/>
             </a:pPr>
             <a:r>
-              <a:rPr lang="fr-FR" sz="6600" b="1" dirty="0" err="1" smtClean="0">
+              <a:rPr lang="fr-FR" sz="6600" b="1" dirty="0" err="1">
                 <a:latin typeface="Cambria" pitchFamily="18" charset="0"/>
               </a:rPr>
               <a:t>Raiso</a:t>
             </a:r>
             <a:r>
-              <a:rPr lang="fr-FR" sz="6600" b="1" dirty="0" smtClean="0">
+              <a:rPr lang="fr-FR" sz="6600" b="1" dirty="0">
                 <a:latin typeface="Cambria" pitchFamily="18" charset="0"/>
               </a:rPr>
               <a:t> </a:t>
             </a:r>
             <a:r>
-              <a:rPr lang="fr-FR" sz="6600" b="1" dirty="0" err="1" smtClean="0">
+              <a:rPr lang="fr-FR" sz="6600" b="1" dirty="0" err="1">
                 <a:latin typeface="Cambria" pitchFamily="18" charset="0"/>
               </a:rPr>
               <a:t>re</a:t>
             </a:r>
             <a:r>
-              <a:rPr lang="fr-FR" sz="6600" b="1" dirty="0" smtClean="0">
+              <a:rPr lang="fr-FR" sz="6600" b="1" dirty="0">
                 <a:latin typeface="Cambria" pitchFamily="18" charset="0"/>
               </a:rPr>
               <a:t> ho </a:t>
             </a:r>
             <a:r>
-              <a:rPr lang="fr-FR" sz="6600" b="1" dirty="0" err="1" smtClean="0">
+              <a:rPr lang="fr-FR" sz="6600" b="1" dirty="0" err="1">
                 <a:latin typeface="Cambria" pitchFamily="18" charset="0"/>
               </a:rPr>
               <a:t>fitahiana</a:t>
             </a:r>
-            <a:endParaRPr lang="fr-FR" sz="6600" b="1" dirty="0" smtClean="0">
+            <a:endParaRPr lang="fr-FR" sz="6600" b="1" dirty="0">
               <a:latin typeface="Cambria" pitchFamily="18" charset="0"/>
             </a:endParaRPr>
           </a:p>
@@ -3750,31 +3728,31 @@
               <a:buNone/>
             </a:pPr>
             <a:r>
-              <a:rPr lang="fr-FR" sz="6600" b="1" dirty="0" smtClean="0">
+              <a:rPr lang="fr-FR" sz="6600" b="1" dirty="0">
                 <a:latin typeface="Cambria" pitchFamily="18" charset="0"/>
               </a:rPr>
               <a:t>'Zay </a:t>
             </a:r>
             <a:r>
-              <a:rPr lang="fr-FR" sz="6600" b="1" dirty="0" err="1" smtClean="0">
+              <a:rPr lang="fr-FR" sz="6600" b="1" dirty="0" err="1">
                 <a:latin typeface="Cambria" pitchFamily="18" charset="0"/>
               </a:rPr>
               <a:t>omen'ny</a:t>
             </a:r>
             <a:r>
-              <a:rPr lang="fr-FR" sz="6600" b="1" dirty="0" smtClean="0">
+              <a:rPr lang="fr-FR" sz="6600" b="1" dirty="0">
                 <a:latin typeface="Cambria" pitchFamily="18" charset="0"/>
               </a:rPr>
               <a:t> </a:t>
             </a:r>
             <a:r>
-              <a:rPr lang="fr-FR" sz="6600" b="1" dirty="0" err="1" smtClean="0">
+              <a:rPr lang="fr-FR" sz="6600" b="1" dirty="0" err="1">
                 <a:latin typeface="Cambria" pitchFamily="18" charset="0"/>
               </a:rPr>
               <a:t>Tomponao</a:t>
             </a:r>
             <a:r>
-              <a:rPr lang="fr-FR" sz="6600" b="1" dirty="0" smtClean="0">
+              <a:rPr lang="fr-FR" sz="6600" b="1" dirty="0">
                 <a:latin typeface="Cambria" pitchFamily="18" charset="0"/>
               </a:rPr>
               <a:t>;</a:t>
@@ -3795,13 +3773,6 @@
   <p:clrMapOvr>
     <a:masterClrMapping/>
   </p:clrMapOvr>
-  <p:timing>
-    <p:tnLst>
-      <p:par>
-        <p:cTn id="1" dur="indefinite" restart="never" nodeType="tmRoot"/>
-      </p:par>
-    </p:tnLst>
-  </p:timing>
 </p:sld>
 </file>
 
@@ -3840,24 +3811,16 @@
         </p:spPr>
         <p:txBody>
           <a:bodyPr>
-            <a:normAutofit fontScale="90000"/>
+            <a:normAutofit/>
           </a:bodyPr>
           <a:lstStyle/>
           <a:p>
             <a:r>
-              <a:rPr lang="fr-FR" dirty="0" smtClean="0">
+              <a:rPr lang="fr-FR" dirty="0">
                 <a:latin typeface="Cambria" pitchFamily="18" charset="0"/>
               </a:rPr>
               <a:t>HIRA 295</a:t>
             </a:r>
-            <a:br>
-              <a:rPr lang="fr-FR" dirty="0" smtClean="0">
-                <a:latin typeface="Cambria" pitchFamily="18" charset="0"/>
-              </a:rPr>
-            </a:br>
-            <a:endParaRPr lang="fr-FR" dirty="0">
-              <a:latin typeface="Cambria" pitchFamily="18" charset="0"/>
-            </a:endParaRPr>
           </a:p>
         </p:txBody>
       </p:sp>
@@ -3887,42 +3850,42 @@
               <a:buNone/>
             </a:pPr>
             <a:r>
-              <a:rPr lang="fr-FR" sz="6100" b="1" dirty="0" smtClean="0">
+              <a:rPr lang="fr-FR" sz="6100" b="1" dirty="0">
                 <a:latin typeface="Cambria" pitchFamily="18" charset="0"/>
               </a:rPr>
               <a:t>Fa </a:t>
             </a:r>
             <a:r>
-              <a:rPr lang="fr-FR" sz="6100" b="1" dirty="0" err="1" smtClean="0">
+              <a:rPr lang="fr-FR" sz="6100" b="1" dirty="0" err="1">
                 <a:latin typeface="Cambria" pitchFamily="18" charset="0"/>
               </a:rPr>
               <a:t>ny</a:t>
             </a:r>
             <a:r>
-              <a:rPr lang="fr-FR" sz="6100" b="1" dirty="0" smtClean="0">
+              <a:rPr lang="fr-FR" sz="6100" b="1" dirty="0">
                 <a:latin typeface="Cambria" pitchFamily="18" charset="0"/>
               </a:rPr>
               <a:t> </a:t>
             </a:r>
             <a:r>
-              <a:rPr lang="fr-FR" sz="6100" b="1" dirty="0" err="1" smtClean="0">
+              <a:rPr lang="fr-FR" sz="6100" b="1" dirty="0" err="1">
                 <a:latin typeface="Cambria" pitchFamily="18" charset="0"/>
               </a:rPr>
               <a:t>lalam</a:t>
             </a:r>
             <a:r>
-              <a:rPr lang="fr-FR" sz="6100" b="1" dirty="0" smtClean="0">
+              <a:rPr lang="fr-FR" sz="6100" b="1" dirty="0">
                 <a:latin typeface="Cambria" pitchFamily="18" charset="0"/>
               </a:rPr>
               <a:t>-</a:t>
             </a:r>
             <a:r>
-              <a:rPr lang="fr-FR" sz="6100" b="1" dirty="0" err="1" smtClean="0">
+              <a:rPr lang="fr-FR" sz="6100" b="1" dirty="0" err="1">
                 <a:latin typeface="Cambria" pitchFamily="18" charset="0"/>
               </a:rPr>
               <a:t>pijaliana</a:t>
             </a:r>
-            <a:endParaRPr lang="fr-FR" sz="6100" b="1" dirty="0" smtClean="0">
+            <a:endParaRPr lang="fr-FR" sz="6100" b="1" dirty="0">
               <a:latin typeface="Cambria" pitchFamily="18" charset="0"/>
             </a:endParaRPr>
           </a:p>
@@ -3931,30 +3894,30 @@
               <a:buNone/>
             </a:pPr>
             <a:r>
-              <a:rPr lang="fr-FR" sz="6100" b="1" dirty="0" smtClean="0">
+              <a:rPr lang="fr-FR" sz="6100" b="1" dirty="0">
                 <a:latin typeface="Cambria" pitchFamily="18" charset="0"/>
               </a:rPr>
               <a:t>'Zay </a:t>
             </a:r>
             <a:r>
-              <a:rPr lang="fr-FR" sz="6100" b="1" dirty="0" err="1" smtClean="0">
+              <a:rPr lang="fr-FR" sz="6100" b="1" dirty="0" err="1">
                 <a:latin typeface="Cambria" pitchFamily="18" charset="0"/>
               </a:rPr>
               <a:t>alehanao</a:t>
             </a:r>
             <a:r>
-              <a:rPr lang="fr-FR" sz="6100" b="1" dirty="0" smtClean="0">
+              <a:rPr lang="fr-FR" sz="6100" b="1" dirty="0">
                 <a:latin typeface="Cambria" pitchFamily="18" charset="0"/>
               </a:rPr>
               <a:t> </a:t>
             </a:r>
             <a:r>
-              <a:rPr lang="fr-FR" sz="6100" b="1" dirty="0" err="1" smtClean="0">
+              <a:rPr lang="fr-FR" sz="6100" b="1" dirty="0" err="1">
                 <a:latin typeface="Cambria" pitchFamily="18" charset="0"/>
               </a:rPr>
               <a:t>izao</a:t>
             </a:r>
-            <a:endParaRPr lang="fr-FR" sz="6100" b="1" dirty="0" smtClean="0">
+            <a:endParaRPr lang="fr-FR" sz="6100" b="1" dirty="0">
               <a:latin typeface="Cambria" pitchFamily="18" charset="0"/>
             </a:endParaRPr>
           </a:p>
@@ -3963,30 +3926,30 @@
               <a:buNone/>
             </a:pPr>
             <a:r>
-              <a:rPr lang="fr-FR" sz="6100" b="1" dirty="0" smtClean="0">
+              <a:rPr lang="fr-FR" sz="6100" b="1" dirty="0">
                 <a:latin typeface="Cambria" pitchFamily="18" charset="0"/>
               </a:rPr>
               <a:t>Dia </a:t>
             </a:r>
             <a:r>
-              <a:rPr lang="fr-FR" sz="6100" b="1" dirty="0" err="1" smtClean="0">
+              <a:rPr lang="fr-FR" sz="6100" b="1" dirty="0" err="1">
                 <a:latin typeface="Cambria" pitchFamily="18" charset="0"/>
               </a:rPr>
               <a:t>mamelom</a:t>
             </a:r>
             <a:r>
-              <a:rPr lang="fr-FR" sz="6100" b="1" dirty="0" smtClean="0">
+              <a:rPr lang="fr-FR" sz="6100" b="1" dirty="0">
                 <a:latin typeface="Cambria" pitchFamily="18" charset="0"/>
               </a:rPr>
               <a:t>-</a:t>
             </a:r>
             <a:r>
-              <a:rPr lang="fr-FR" sz="6100" b="1" dirty="0" err="1" smtClean="0">
+              <a:rPr lang="fr-FR" sz="6100" b="1" dirty="0" err="1">
                 <a:latin typeface="Cambria" pitchFamily="18" charset="0"/>
               </a:rPr>
               <a:t>paniriana</a:t>
             </a:r>
-            <a:endParaRPr lang="fr-FR" sz="6100" b="1" dirty="0" smtClean="0">
+            <a:endParaRPr lang="fr-FR" sz="6100" b="1" dirty="0">
               <a:latin typeface="Cambria" pitchFamily="18" charset="0"/>
             </a:endParaRPr>
           </a:p>
@@ -3995,25 +3958,25 @@
               <a:buNone/>
             </a:pPr>
             <a:r>
-              <a:rPr lang="fr-FR" sz="6100" b="1" dirty="0" err="1" smtClean="0">
+              <a:rPr lang="fr-FR" sz="6100" b="1" dirty="0" err="1">
                 <a:latin typeface="Cambria" pitchFamily="18" charset="0"/>
               </a:rPr>
               <a:t>Hitomboan'ny</a:t>
             </a:r>
             <a:r>
-              <a:rPr lang="fr-FR" sz="6100" b="1" dirty="0" smtClean="0">
+              <a:rPr lang="fr-FR" sz="6100" b="1" dirty="0">
                 <a:latin typeface="Cambria" pitchFamily="18" charset="0"/>
               </a:rPr>
               <a:t> </a:t>
             </a:r>
             <a:r>
-              <a:rPr lang="fr-FR" sz="6100" b="1" dirty="0" err="1" smtClean="0">
+              <a:rPr lang="fr-FR" sz="6100" b="1" dirty="0" err="1">
                 <a:latin typeface="Cambria" pitchFamily="18" charset="0"/>
               </a:rPr>
               <a:t>herinao</a:t>
             </a:r>
             <a:r>
-              <a:rPr lang="fr-FR" sz="6100" b="1" dirty="0" smtClean="0">
+              <a:rPr lang="fr-FR" sz="6100" b="1" dirty="0">
                 <a:latin typeface="Cambria" pitchFamily="18" charset="0"/>
               </a:rPr>
               <a:t>.</a:t>
@@ -4034,13 +3997,6 @@
   <p:clrMapOvr>
     <a:masterClrMapping/>
   </p:clrMapOvr>
-  <p:timing>
-    <p:tnLst>
-      <p:par>
-        <p:cTn id="1" dur="indefinite" restart="never" nodeType="tmRoot"/>
-      </p:par>
-    </p:tnLst>
-  </p:timing>
 </p:sld>
 </file>
 
@@ -4079,24 +4035,16 @@
         </p:spPr>
         <p:txBody>
           <a:bodyPr>
-            <a:normAutofit fontScale="90000"/>
+            <a:normAutofit/>
           </a:bodyPr>
           <a:lstStyle/>
           <a:p>
             <a:r>
-              <a:rPr lang="fr-FR" dirty="0" smtClean="0">
+              <a:rPr lang="fr-FR" dirty="0">
                 <a:latin typeface="Cambria" pitchFamily="18" charset="0"/>
               </a:rPr>
               <a:t>HIRA 295</a:t>
             </a:r>
-            <a:br>
-              <a:rPr lang="fr-FR" dirty="0" smtClean="0">
-                <a:latin typeface="Cambria" pitchFamily="18" charset="0"/>
-              </a:rPr>
-            </a:br>
-            <a:endParaRPr lang="fr-FR" dirty="0">
-              <a:latin typeface="Cambria" pitchFamily="18" charset="0"/>
-            </a:endParaRPr>
           </a:p>
         </p:txBody>
       </p:sp>
@@ -4126,60 +4074,60 @@
               <a:buNone/>
             </a:pPr>
             <a:r>
-              <a:rPr lang="en-US" sz="6100" b="1" dirty="0" smtClean="0">
+              <a:rPr lang="en-US" sz="6100" b="1" dirty="0">
                 <a:latin typeface="Cambria" pitchFamily="18" charset="0"/>
               </a:rPr>
               <a:t>3. </a:t>
             </a:r>
             <a:r>
-              <a:rPr lang="en-US" sz="6100" b="1" dirty="0" err="1" smtClean="0">
+              <a:rPr lang="en-US" sz="6100" b="1" dirty="0" err="1">
                 <a:latin typeface="Cambria" pitchFamily="18" charset="0"/>
               </a:rPr>
               <a:t>Miadia</a:t>
             </a:r>
             <a:r>
-              <a:rPr lang="en-US" sz="6100" b="1" dirty="0" smtClean="0">
+              <a:rPr lang="en-US" sz="6100" b="1" dirty="0">
                 <a:latin typeface="Cambria" pitchFamily="18" charset="0"/>
               </a:rPr>
               <a:t> </a:t>
             </a:r>
             <a:r>
-              <a:rPr lang="en-US" sz="6100" b="1" dirty="0" err="1" smtClean="0">
+              <a:rPr lang="en-US" sz="6100" b="1" dirty="0" err="1">
                 <a:latin typeface="Cambria" pitchFamily="18" charset="0"/>
               </a:rPr>
               <a:t>ny</a:t>
             </a:r>
             <a:r>
-              <a:rPr lang="en-US" sz="6100" b="1" dirty="0" smtClean="0">
+              <a:rPr lang="en-US" sz="6100" b="1" dirty="0">
                 <a:latin typeface="Cambria" pitchFamily="18" charset="0"/>
               </a:rPr>
               <a:t> </a:t>
             </a:r>
             <a:r>
-              <a:rPr lang="en-US" sz="6100" b="1" dirty="0" err="1" smtClean="0">
+              <a:rPr lang="en-US" sz="6100" b="1" dirty="0" err="1">
                 <a:latin typeface="Cambria" pitchFamily="18" charset="0"/>
               </a:rPr>
               <a:t>ady</a:t>
             </a:r>
             <a:r>
-              <a:rPr lang="en-US" sz="6100" b="1" dirty="0" smtClean="0">
+              <a:rPr lang="en-US" sz="6100" b="1" dirty="0">
                 <a:latin typeface="Cambria" pitchFamily="18" charset="0"/>
               </a:rPr>
               <a:t> </a:t>
             </a:r>
             <a:r>
-              <a:rPr lang="en-US" sz="6100" b="1" dirty="0" err="1" smtClean="0">
+              <a:rPr lang="en-US" sz="6100" b="1" dirty="0" err="1">
                 <a:latin typeface="Cambria" pitchFamily="18" charset="0"/>
               </a:rPr>
               <a:t>tsara</a:t>
             </a:r>
             <a:r>
-              <a:rPr lang="en-US" sz="6100" b="1" dirty="0" smtClean="0">
+              <a:rPr lang="en-US" sz="6100" b="1" dirty="0">
                 <a:latin typeface="Cambria" pitchFamily="18" charset="0"/>
               </a:rPr>
               <a:t>,</a:t>
             </a:r>
-            <a:endParaRPr lang="fr-FR" sz="6100" b="1" dirty="0" smtClean="0">
+            <a:endParaRPr lang="fr-FR" sz="6100" b="1" dirty="0">
               <a:latin typeface="Cambria" pitchFamily="18" charset="0"/>
             </a:endParaRPr>
           </a:p>
@@ -4188,36 +4136,36 @@
               <a:buNone/>
             </a:pPr>
             <a:r>
-              <a:rPr lang="en-US" sz="6100" b="1" dirty="0" smtClean="0">
+              <a:rPr lang="en-US" sz="6100" b="1" dirty="0">
                 <a:latin typeface="Cambria" pitchFamily="18" charset="0"/>
               </a:rPr>
               <a:t>Ho </a:t>
             </a:r>
             <a:r>
-              <a:rPr lang="en-US" sz="6100" b="1" dirty="0" err="1" smtClean="0">
+              <a:rPr lang="en-US" sz="6100" b="1" dirty="0" err="1">
                 <a:latin typeface="Cambria" pitchFamily="18" charset="0"/>
               </a:rPr>
               <a:t>mpandresy</a:t>
             </a:r>
             <a:r>
-              <a:rPr lang="en-US" sz="6100" b="1" dirty="0" smtClean="0">
+              <a:rPr lang="en-US" sz="6100" b="1" dirty="0">
                 <a:latin typeface="Cambria" pitchFamily="18" charset="0"/>
               </a:rPr>
               <a:t> </a:t>
             </a:r>
             <a:r>
-              <a:rPr lang="en-US" sz="6100" b="1" dirty="0" err="1" smtClean="0">
+              <a:rPr lang="en-US" sz="6100" b="1" dirty="0" err="1">
                 <a:latin typeface="Cambria" pitchFamily="18" charset="0"/>
               </a:rPr>
               <a:t>hianao</a:t>
             </a:r>
             <a:r>
-              <a:rPr lang="en-US" sz="6100" b="1" dirty="0" smtClean="0">
+              <a:rPr lang="en-US" sz="6100" b="1" dirty="0">
                 <a:latin typeface="Cambria" pitchFamily="18" charset="0"/>
               </a:rPr>
               <a:t>;</a:t>
             </a:r>
-            <a:endParaRPr lang="fr-FR" sz="6100" b="1" dirty="0" smtClean="0">
+            <a:endParaRPr lang="fr-FR" sz="6100" b="1" dirty="0">
               <a:latin typeface="Cambria" pitchFamily="18" charset="0"/>
             </a:endParaRPr>
           </a:p>
@@ -4226,36 +4174,36 @@
               <a:buNone/>
             </a:pPr>
             <a:r>
-              <a:rPr lang="en-US" sz="6100" b="1" dirty="0" err="1" smtClean="0">
+              <a:rPr lang="en-US" sz="6100" b="1" dirty="0" err="1">
                 <a:latin typeface="Cambria" pitchFamily="18" charset="0"/>
               </a:rPr>
               <a:t>Tontosay</a:t>
             </a:r>
             <a:r>
-              <a:rPr lang="en-US" sz="6100" b="1" dirty="0" smtClean="0">
+              <a:rPr lang="en-US" sz="6100" b="1" dirty="0">
                 <a:latin typeface="Cambria" pitchFamily="18" charset="0"/>
               </a:rPr>
               <a:t> </a:t>
             </a:r>
             <a:r>
-              <a:rPr lang="en-US" sz="6100" b="1" dirty="0" err="1" smtClean="0">
+              <a:rPr lang="en-US" sz="6100" b="1" dirty="0" err="1">
                 <a:latin typeface="Cambria" pitchFamily="18" charset="0"/>
               </a:rPr>
               <a:t>izay</a:t>
             </a:r>
             <a:r>
-              <a:rPr lang="en-US" sz="6100" b="1" dirty="0" smtClean="0">
+              <a:rPr lang="en-US" sz="6100" b="1" dirty="0">
                 <a:latin typeface="Cambria" pitchFamily="18" charset="0"/>
               </a:rPr>
               <a:t> </a:t>
             </a:r>
             <a:r>
-              <a:rPr lang="en-US" sz="6100" b="1" dirty="0" err="1" smtClean="0">
+              <a:rPr lang="en-US" sz="6100" b="1" dirty="0" err="1">
                 <a:latin typeface="Cambria" pitchFamily="18" charset="0"/>
               </a:rPr>
               <a:t>anjara</a:t>
             </a:r>
-            <a:endParaRPr lang="fr-FR" sz="6100" b="1" dirty="0" smtClean="0">
+            <a:endParaRPr lang="fr-FR" sz="6100" b="1" dirty="0">
               <a:latin typeface="Cambria" pitchFamily="18" charset="0"/>
             </a:endParaRPr>
           </a:p>
@@ -4264,30 +4212,30 @@
               <a:buNone/>
             </a:pPr>
             <a:r>
-              <a:rPr lang="en-US" sz="6100" b="1" dirty="0" err="1" smtClean="0">
+              <a:rPr lang="en-US" sz="6100" b="1" dirty="0" err="1">
                 <a:latin typeface="Cambria" pitchFamily="18" charset="0"/>
               </a:rPr>
               <a:t>Eo</a:t>
             </a:r>
             <a:r>
-              <a:rPr lang="en-US" sz="6100" b="1" dirty="0" smtClean="0">
+              <a:rPr lang="en-US" sz="6100" b="1" dirty="0">
                 <a:latin typeface="Cambria" pitchFamily="18" charset="0"/>
               </a:rPr>
               <a:t> am-</a:t>
             </a:r>
             <a:r>
-              <a:rPr lang="en-US" sz="6100" b="1" dirty="0" err="1" smtClean="0">
+              <a:rPr lang="en-US" sz="6100" b="1" dirty="0" err="1">
                 <a:latin typeface="Cambria" pitchFamily="18" charset="0"/>
               </a:rPr>
               <a:t>pelantananao</a:t>
             </a:r>
             <a:r>
-              <a:rPr lang="en-US" sz="6100" b="1" dirty="0" smtClean="0">
+              <a:rPr lang="en-US" sz="6100" b="1" dirty="0">
                 <a:latin typeface="Cambria" pitchFamily="18" charset="0"/>
               </a:rPr>
               <a:t>;</a:t>
             </a:r>
-            <a:endParaRPr lang="fr-FR" sz="6100" b="1" dirty="0" smtClean="0">
+            <a:endParaRPr lang="fr-FR" sz="6100" b="1" dirty="0">
               <a:latin typeface="Cambria" pitchFamily="18" charset="0"/>
             </a:endParaRPr>
           </a:p>
@@ -4306,13 +4254,6 @@
   <p:clrMapOvr>
     <a:masterClrMapping/>
   </p:clrMapOvr>
-  <p:timing>
-    <p:tnLst>
-      <p:par>
-        <p:cTn id="1" dur="indefinite" restart="never" nodeType="tmRoot"/>
-      </p:par>
-    </p:tnLst>
-  </p:timing>
 </p:sld>
 </file>
 
@@ -4351,24 +4292,16 @@
         </p:spPr>
         <p:txBody>
           <a:bodyPr>
-            <a:normAutofit fontScale="90000"/>
+            <a:normAutofit/>
           </a:bodyPr>
           <a:lstStyle/>
           <a:p>
             <a:r>
-              <a:rPr lang="fr-FR" dirty="0" smtClean="0">
+              <a:rPr lang="fr-FR" dirty="0">
                 <a:latin typeface="Cambria" pitchFamily="18" charset="0"/>
               </a:rPr>
               <a:t>HIRA 295</a:t>
             </a:r>
-            <a:br>
-              <a:rPr lang="fr-FR" dirty="0" smtClean="0">
-                <a:latin typeface="Cambria" pitchFamily="18" charset="0"/>
-              </a:rPr>
-            </a:br>
-            <a:endParaRPr lang="fr-FR" dirty="0">
-              <a:latin typeface="Cambria" pitchFamily="18" charset="0"/>
-            </a:endParaRPr>
           </a:p>
         </p:txBody>
       </p:sp>
@@ -4398,36 +4331,36 @@
               <a:buNone/>
             </a:pPr>
             <a:r>
-              <a:rPr lang="fr-FR" sz="6100" b="1" dirty="0" err="1" smtClean="0">
+              <a:rPr lang="fr-FR" sz="6100" b="1" dirty="0" err="1">
                 <a:latin typeface="Cambria" pitchFamily="18" charset="0"/>
               </a:rPr>
               <a:t>Jeso</a:t>
             </a:r>
             <a:r>
-              <a:rPr lang="fr-FR" sz="6100" b="1" dirty="0" smtClean="0">
+              <a:rPr lang="fr-FR" sz="6100" b="1" dirty="0">
                 <a:latin typeface="Cambria" pitchFamily="18" charset="0"/>
               </a:rPr>
               <a:t> </a:t>
             </a:r>
             <a:r>
-              <a:rPr lang="fr-FR" sz="6100" b="1" dirty="0" err="1" smtClean="0">
+              <a:rPr lang="fr-FR" sz="6100" b="1" dirty="0" err="1">
                 <a:latin typeface="Cambria" pitchFamily="18" charset="0"/>
               </a:rPr>
               <a:t>Tompo</a:t>
             </a:r>
             <a:r>
-              <a:rPr lang="fr-FR" sz="6100" b="1" dirty="0" smtClean="0">
+              <a:rPr lang="fr-FR" sz="6100" b="1" dirty="0">
                 <a:latin typeface="Cambria" pitchFamily="18" charset="0"/>
               </a:rPr>
               <a:t> no </a:t>
             </a:r>
             <a:r>
-              <a:rPr lang="fr-FR" sz="6100" b="1" dirty="0" err="1" smtClean="0">
+              <a:rPr lang="fr-FR" sz="6100" b="1" dirty="0" err="1">
                 <a:latin typeface="Cambria" pitchFamily="18" charset="0"/>
               </a:rPr>
               <a:t>mijery</a:t>
             </a:r>
-            <a:endParaRPr lang="fr-FR" sz="6100" b="1" dirty="0" smtClean="0">
+            <a:endParaRPr lang="fr-FR" sz="6100" b="1" dirty="0">
               <a:latin typeface="Cambria" pitchFamily="18" charset="0"/>
             </a:endParaRPr>
           </a:p>
@@ -4436,49 +4369,49 @@
               <a:buNone/>
             </a:pPr>
             <a:r>
-              <a:rPr lang="fr-FR" sz="6100" b="1" dirty="0" err="1" smtClean="0">
+              <a:rPr lang="fr-FR" sz="6100" b="1" dirty="0" err="1">
                 <a:latin typeface="Cambria" pitchFamily="18" charset="0"/>
               </a:rPr>
               <a:t>Sy</a:t>
             </a:r>
             <a:r>
-              <a:rPr lang="fr-FR" sz="6100" b="1" dirty="0" smtClean="0">
+              <a:rPr lang="fr-FR" sz="6100" b="1" dirty="0">
                 <a:latin typeface="Cambria" pitchFamily="18" charset="0"/>
               </a:rPr>
               <a:t> </a:t>
             </a:r>
             <a:r>
-              <a:rPr lang="fr-FR" sz="6100" b="1" dirty="0" err="1" smtClean="0">
+              <a:rPr lang="fr-FR" sz="6100" b="1" dirty="0" err="1">
                 <a:latin typeface="Cambria" pitchFamily="18" charset="0"/>
               </a:rPr>
               <a:t>mahita</a:t>
             </a:r>
             <a:r>
-              <a:rPr lang="fr-FR" sz="6100" b="1" dirty="0" smtClean="0">
+              <a:rPr lang="fr-FR" sz="6100" b="1" dirty="0">
                 <a:latin typeface="Cambria" pitchFamily="18" charset="0"/>
               </a:rPr>
               <a:t> </a:t>
             </a:r>
             <a:r>
-              <a:rPr lang="fr-FR" sz="6100" b="1" dirty="0" err="1" smtClean="0">
+              <a:rPr lang="fr-FR" sz="6100" b="1" dirty="0" err="1">
                 <a:latin typeface="Cambria" pitchFamily="18" charset="0"/>
               </a:rPr>
               <a:t>ny</a:t>
             </a:r>
             <a:r>
-              <a:rPr lang="fr-FR" sz="6100" b="1" dirty="0" smtClean="0">
+              <a:rPr lang="fr-FR" sz="6100" b="1" dirty="0">
                 <a:latin typeface="Cambria" pitchFamily="18" charset="0"/>
               </a:rPr>
               <a:t> </a:t>
             </a:r>
             <a:r>
-              <a:rPr lang="fr-FR" sz="6100" b="1" dirty="0" err="1" smtClean="0">
+              <a:rPr lang="fr-FR" sz="6100" b="1" dirty="0" err="1">
                 <a:latin typeface="Cambria" pitchFamily="18" charset="0"/>
               </a:rPr>
               <a:t>atao</a:t>
             </a:r>
             <a:r>
-              <a:rPr lang="fr-FR" sz="6100" b="1" dirty="0" smtClean="0">
+              <a:rPr lang="fr-FR" sz="6100" b="1" dirty="0">
                 <a:latin typeface="Cambria" pitchFamily="18" charset="0"/>
               </a:rPr>
               <a:t>,</a:t>
@@ -4489,60 +4422,60 @@
               <a:buNone/>
             </a:pPr>
             <a:r>
-              <a:rPr lang="fr-FR" sz="6100" b="1" dirty="0" err="1" smtClean="0">
+              <a:rPr lang="fr-FR" sz="6100" b="1" dirty="0" err="1">
                 <a:latin typeface="Cambria" pitchFamily="18" charset="0"/>
               </a:rPr>
               <a:t>Koa</a:t>
             </a:r>
             <a:r>
-              <a:rPr lang="fr-FR" sz="6100" b="1" dirty="0" smtClean="0">
+              <a:rPr lang="fr-FR" sz="6100" b="1" dirty="0">
                 <a:latin typeface="Cambria" pitchFamily="18" charset="0"/>
               </a:rPr>
               <a:t> </a:t>
             </a:r>
             <a:r>
-              <a:rPr lang="fr-FR" sz="6100" b="1" dirty="0" err="1" smtClean="0">
+              <a:rPr lang="fr-FR" sz="6100" b="1" dirty="0" err="1">
                 <a:latin typeface="Cambria" pitchFamily="18" charset="0"/>
               </a:rPr>
               <a:t>tsy</a:t>
             </a:r>
             <a:r>
-              <a:rPr lang="fr-FR" sz="6100" b="1" dirty="0" smtClean="0">
+              <a:rPr lang="fr-FR" sz="6100" b="1" dirty="0">
                 <a:latin typeface="Cambria" pitchFamily="18" charset="0"/>
               </a:rPr>
               <a:t> </a:t>
             </a:r>
             <a:r>
-              <a:rPr lang="fr-FR" sz="6100" b="1" dirty="0" err="1" smtClean="0">
+              <a:rPr lang="fr-FR" sz="6100" b="1" dirty="0" err="1">
                 <a:latin typeface="Cambria" pitchFamily="18" charset="0"/>
               </a:rPr>
               <a:t>mba</a:t>
             </a:r>
             <a:r>
-              <a:rPr lang="fr-FR" sz="6100" b="1" dirty="0" smtClean="0">
+              <a:rPr lang="fr-FR" sz="6100" b="1" dirty="0">
                 <a:latin typeface="Cambria" pitchFamily="18" charset="0"/>
               </a:rPr>
               <a:t> </a:t>
             </a:r>
             <a:r>
-              <a:rPr lang="fr-FR" sz="6100" b="1" dirty="0" err="1" smtClean="0">
+              <a:rPr lang="fr-FR" sz="6100" b="1" dirty="0" err="1">
                 <a:latin typeface="Cambria" pitchFamily="18" charset="0"/>
               </a:rPr>
               <a:t>hisy</a:t>
             </a:r>
             <a:r>
-              <a:rPr lang="fr-FR" sz="6100" b="1" dirty="0" smtClean="0">
+              <a:rPr lang="fr-FR" sz="6100" b="1" dirty="0">
                 <a:latin typeface="Cambria" pitchFamily="18" charset="0"/>
               </a:rPr>
               <a:t> </a:t>
             </a:r>
             <a:r>
-              <a:rPr lang="fr-FR" sz="6100" b="1" dirty="0" err="1" smtClean="0">
+              <a:rPr lang="fr-FR" sz="6100" b="1" dirty="0" err="1">
                 <a:latin typeface="Cambria" pitchFamily="18" charset="0"/>
               </a:rPr>
               <a:t>very</a:t>
             </a:r>
-            <a:endParaRPr lang="fr-FR" sz="6100" b="1" dirty="0" smtClean="0">
+            <a:endParaRPr lang="fr-FR" sz="6100" b="1" dirty="0">
               <a:latin typeface="Cambria" pitchFamily="18" charset="0"/>
             </a:endParaRPr>
           </a:p>
@@ -4551,31 +4484,31 @@
               <a:buNone/>
             </a:pPr>
             <a:r>
-              <a:rPr lang="fr-FR" sz="6100" b="1" dirty="0" smtClean="0">
+              <a:rPr lang="fr-FR" sz="6100" b="1" dirty="0">
                 <a:latin typeface="Cambria" pitchFamily="18" charset="0"/>
               </a:rPr>
               <a:t>'Zay </a:t>
             </a:r>
             <a:r>
-              <a:rPr lang="fr-FR" sz="6100" b="1" dirty="0" err="1" smtClean="0">
+              <a:rPr lang="fr-FR" sz="6100" b="1" dirty="0" err="1">
                 <a:latin typeface="Cambria" pitchFamily="18" charset="0"/>
               </a:rPr>
               <a:t>rehetra</a:t>
             </a:r>
             <a:r>
-              <a:rPr lang="fr-FR" sz="6100" b="1" dirty="0" smtClean="0">
+              <a:rPr lang="fr-FR" sz="6100" b="1" dirty="0">
                 <a:latin typeface="Cambria" pitchFamily="18" charset="0"/>
               </a:rPr>
               <a:t> </a:t>
             </a:r>
             <a:r>
-              <a:rPr lang="fr-FR" sz="6100" b="1" dirty="0" err="1" smtClean="0">
+              <a:rPr lang="fr-FR" sz="6100" b="1" dirty="0" err="1">
                 <a:latin typeface="Cambria" pitchFamily="18" charset="0"/>
               </a:rPr>
               <a:t>vitanao</a:t>
             </a:r>
             <a:r>
-              <a:rPr lang="fr-FR" sz="6100" b="1" dirty="0" smtClean="0">
+              <a:rPr lang="fr-FR" sz="6100" b="1" dirty="0">
                 <a:latin typeface="Cambria" pitchFamily="18" charset="0"/>
               </a:rPr>
               <a:t>.</a:t>
@@ -4596,13 +4529,6 @@
   <p:clrMapOvr>
     <a:masterClrMapping/>
   </p:clrMapOvr>
-  <p:timing>
-    <p:tnLst>
-      <p:par>
-        <p:cTn id="1" dur="indefinite" restart="never" nodeType="tmRoot"/>
-      </p:par>
-    </p:tnLst>
-  </p:timing>
 </p:sld>
 </file>
 
@@ -4641,24 +4567,16 @@
         </p:spPr>
         <p:txBody>
           <a:bodyPr>
-            <a:normAutofit fontScale="90000"/>
+            <a:normAutofit/>
           </a:bodyPr>
           <a:lstStyle/>
           <a:p>
             <a:r>
-              <a:rPr lang="fr-FR" dirty="0" smtClean="0">
+              <a:rPr lang="fr-FR" dirty="0">
                 <a:latin typeface="Cambria" pitchFamily="18" charset="0"/>
               </a:rPr>
               <a:t>HIRA 295</a:t>
             </a:r>
-            <a:br>
-              <a:rPr lang="fr-FR" dirty="0" smtClean="0">
-                <a:latin typeface="Cambria" pitchFamily="18" charset="0"/>
-              </a:rPr>
-            </a:br>
-            <a:endParaRPr lang="fr-FR" dirty="0">
-              <a:latin typeface="Cambria" pitchFamily="18" charset="0"/>
-            </a:endParaRPr>
           </a:p>
         </p:txBody>
       </p:sp>
@@ -4688,42 +4606,42 @@
               <a:buNone/>
             </a:pPr>
             <a:r>
-              <a:rPr lang="fr-FR" sz="6100" b="1" dirty="0" smtClean="0">
+              <a:rPr lang="fr-FR" sz="6100" b="1" dirty="0">
                 <a:latin typeface="Cambria" pitchFamily="18" charset="0"/>
               </a:rPr>
               <a:t>4. </a:t>
             </a:r>
             <a:r>
-              <a:rPr lang="fr-FR" sz="6100" b="1" dirty="0" err="1" smtClean="0">
+              <a:rPr lang="fr-FR" sz="6100" b="1" dirty="0" err="1">
                 <a:latin typeface="Cambria" pitchFamily="18" charset="0"/>
               </a:rPr>
               <a:t>Ry</a:t>
             </a:r>
             <a:r>
-              <a:rPr lang="fr-FR" sz="6100" b="1" dirty="0" smtClean="0">
+              <a:rPr lang="fr-FR" sz="6100" b="1" dirty="0">
                 <a:latin typeface="Cambria" pitchFamily="18" charset="0"/>
               </a:rPr>
               <a:t> </a:t>
             </a:r>
             <a:r>
-              <a:rPr lang="fr-FR" sz="6100" b="1" dirty="0" err="1" smtClean="0">
+              <a:rPr lang="fr-FR" sz="6100" b="1" dirty="0" err="1">
                 <a:latin typeface="Cambria" pitchFamily="18" charset="0"/>
               </a:rPr>
               <a:t>Jesosy</a:t>
             </a:r>
             <a:r>
-              <a:rPr lang="fr-FR" sz="6100" b="1" dirty="0" smtClean="0">
+              <a:rPr lang="fr-FR" sz="6100" b="1" dirty="0">
                 <a:latin typeface="Cambria" pitchFamily="18" charset="0"/>
               </a:rPr>
               <a:t>! </a:t>
             </a:r>
             <a:r>
-              <a:rPr lang="fr-FR" sz="6100" b="1" dirty="0" err="1" smtClean="0">
+              <a:rPr lang="fr-FR" sz="6100" b="1" dirty="0" err="1">
                 <a:latin typeface="Cambria" pitchFamily="18" charset="0"/>
               </a:rPr>
               <a:t>hantajaho</a:t>
             </a:r>
-            <a:endParaRPr lang="fr-FR" sz="6100" b="1" dirty="0" smtClean="0">
+            <a:endParaRPr lang="fr-FR" sz="6100" b="1" dirty="0">
               <a:latin typeface="Cambria" pitchFamily="18" charset="0"/>
             </a:endParaRPr>
           </a:p>
@@ -4732,43 +4650,43 @@
               <a:buNone/>
             </a:pPr>
             <a:r>
-              <a:rPr lang="fr-FR" sz="6100" b="1" dirty="0" smtClean="0">
+              <a:rPr lang="fr-FR" sz="6100" b="1" dirty="0">
                 <a:latin typeface="Cambria" pitchFamily="18" charset="0"/>
               </a:rPr>
               <a:t>'</a:t>
             </a:r>
             <a:r>
-              <a:rPr lang="fr-FR" sz="6100" b="1" dirty="0" err="1" smtClean="0">
+              <a:rPr lang="fr-FR" sz="6100" b="1" dirty="0" err="1">
                 <a:latin typeface="Cambria" pitchFamily="18" charset="0"/>
               </a:rPr>
               <a:t>Ty</a:t>
             </a:r>
             <a:r>
-              <a:rPr lang="fr-FR" sz="6100" b="1" dirty="0" smtClean="0">
+              <a:rPr lang="fr-FR" sz="6100" b="1" dirty="0">
                 <a:latin typeface="Cambria" pitchFamily="18" charset="0"/>
               </a:rPr>
               <a:t> </a:t>
             </a:r>
             <a:r>
-              <a:rPr lang="fr-FR" sz="6100" b="1" dirty="0" err="1" smtClean="0">
+              <a:rPr lang="fr-FR" sz="6100" b="1" dirty="0" err="1">
                 <a:latin typeface="Cambria" pitchFamily="18" charset="0"/>
               </a:rPr>
               <a:t>mpanolo</a:t>
             </a:r>
             <a:r>
-              <a:rPr lang="fr-FR" sz="6100" b="1" dirty="0" smtClean="0">
+              <a:rPr lang="fr-FR" sz="6100" b="1" dirty="0">
                 <a:latin typeface="Cambria" pitchFamily="18" charset="0"/>
               </a:rPr>
               <a:t>-</a:t>
             </a:r>
             <a:r>
-              <a:rPr lang="fr-FR" sz="6100" b="1" dirty="0" err="1" smtClean="0">
+              <a:rPr lang="fr-FR" sz="6100" b="1" dirty="0" err="1">
                 <a:latin typeface="Cambria" pitchFamily="18" charset="0"/>
               </a:rPr>
               <a:t>tenanao</a:t>
             </a:r>
             <a:r>
-              <a:rPr lang="fr-FR" sz="6100" b="1" dirty="0" smtClean="0">
+              <a:rPr lang="fr-FR" sz="6100" b="1" dirty="0">
                 <a:latin typeface="Cambria" pitchFamily="18" charset="0"/>
               </a:rPr>
               <a:t>,</a:t>
@@ -4779,25 +4697,25 @@
               <a:buNone/>
             </a:pPr>
             <a:r>
-              <a:rPr lang="fr-FR" sz="6100" b="1" dirty="0" err="1" smtClean="0">
+              <a:rPr lang="fr-FR" sz="6100" b="1" dirty="0" err="1">
                 <a:latin typeface="Cambria" pitchFamily="18" charset="0"/>
               </a:rPr>
               <a:t>Miangavy</a:t>
             </a:r>
             <a:r>
-              <a:rPr lang="fr-FR" sz="6100" b="1" dirty="0" smtClean="0">
+              <a:rPr lang="fr-FR" sz="6100" b="1" dirty="0">
                 <a:latin typeface="Cambria" pitchFamily="18" charset="0"/>
               </a:rPr>
               <a:t>, </a:t>
             </a:r>
             <a:r>
-              <a:rPr lang="fr-FR" sz="6100" b="1" dirty="0" err="1" smtClean="0">
+              <a:rPr lang="fr-FR" sz="6100" b="1" dirty="0" err="1">
                 <a:latin typeface="Cambria" pitchFamily="18" charset="0"/>
               </a:rPr>
               <a:t>mitalaho</a:t>
             </a:r>
             <a:r>
-              <a:rPr lang="fr-FR" sz="6100" b="1" dirty="0" smtClean="0">
+              <a:rPr lang="fr-FR" sz="6100" b="1" dirty="0">
                 <a:latin typeface="Cambria" pitchFamily="18" charset="0"/>
               </a:rPr>
               <a:t>,</a:t>
@@ -4808,31 +4726,31 @@
               <a:buNone/>
             </a:pPr>
             <a:r>
-              <a:rPr lang="fr-FR" sz="6100" b="1" dirty="0" smtClean="0">
+              <a:rPr lang="fr-FR" sz="6100" b="1" dirty="0">
                 <a:latin typeface="Cambria" pitchFamily="18" charset="0"/>
               </a:rPr>
               <a:t>Ka </a:t>
             </a:r>
             <a:r>
-              <a:rPr lang="fr-FR" sz="6100" b="1" dirty="0" err="1" smtClean="0">
+              <a:rPr lang="fr-FR" sz="6100" b="1" dirty="0" err="1">
                 <a:latin typeface="Cambria" pitchFamily="18" charset="0"/>
               </a:rPr>
               <a:t>iteneno</a:t>
             </a:r>
             <a:r>
-              <a:rPr lang="fr-FR" sz="6100" b="1" dirty="0" smtClean="0">
+              <a:rPr lang="fr-FR" sz="6100" b="1" dirty="0">
                 <a:latin typeface="Cambria" pitchFamily="18" charset="0"/>
               </a:rPr>
               <a:t>, </a:t>
             </a:r>
             <a:r>
-              <a:rPr lang="fr-FR" sz="6100" b="1" dirty="0" err="1" smtClean="0">
+              <a:rPr lang="fr-FR" sz="6100" b="1" dirty="0" err="1">
                 <a:latin typeface="Cambria" pitchFamily="18" charset="0"/>
               </a:rPr>
               <a:t>Tompo</a:t>
             </a:r>
             <a:r>
-              <a:rPr lang="fr-FR" sz="6100" b="1" dirty="0" smtClean="0">
+              <a:rPr lang="fr-FR" sz="6100" b="1" dirty="0">
                 <a:latin typeface="Cambria" pitchFamily="18" charset="0"/>
               </a:rPr>
               <a:t> ô!</a:t>
@@ -4853,13 +4771,6 @@
   <p:clrMapOvr>
     <a:masterClrMapping/>
   </p:clrMapOvr>
-  <p:timing>
-    <p:tnLst>
-      <p:par>
-        <p:cTn id="1" dur="indefinite" restart="never" nodeType="tmRoot"/>
-      </p:par>
-    </p:tnLst>
-  </p:timing>
 </p:sld>
 </file>
 
@@ -4903,24 +4814,16 @@
         </p:spPr>
         <p:txBody>
           <a:bodyPr>
-            <a:normAutofit fontScale="90000"/>
+            <a:normAutofit/>
           </a:bodyPr>
           <a:lstStyle/>
           <a:p>
             <a:r>
-              <a:rPr lang="fr-FR" dirty="0" smtClean="0">
+              <a:rPr lang="fr-FR" dirty="0">
                 <a:latin typeface="Cambria" pitchFamily="18" charset="0"/>
               </a:rPr>
               <a:t>HIRA 295</a:t>
             </a:r>
-            <a:br>
-              <a:rPr lang="fr-FR" dirty="0" smtClean="0">
-                <a:latin typeface="Cambria" pitchFamily="18" charset="0"/>
-              </a:rPr>
-            </a:br>
-            <a:endParaRPr lang="fr-FR" dirty="0">
-              <a:latin typeface="Cambria" pitchFamily="18" charset="0"/>
-            </a:endParaRPr>
           </a:p>
         </p:txBody>
       </p:sp>
@@ -4950,54 +4853,54 @@
               <a:buNone/>
             </a:pPr>
             <a:r>
-              <a:rPr lang="fr-FR" sz="6100" b="1" dirty="0" smtClean="0">
+              <a:rPr lang="fr-FR" sz="6100" b="1" dirty="0">
                 <a:latin typeface="Cambria" pitchFamily="18" charset="0"/>
               </a:rPr>
               <a:t>  </a:t>
             </a:r>
             <a:r>
-              <a:rPr lang="fr-FR" sz="6100" b="1" dirty="0" err="1" smtClean="0">
+              <a:rPr lang="fr-FR" sz="6100" b="1" dirty="0" err="1">
                 <a:latin typeface="Cambria" pitchFamily="18" charset="0"/>
               </a:rPr>
               <a:t>Aoka</a:t>
             </a:r>
             <a:r>
-              <a:rPr lang="fr-FR" sz="6100" b="1" dirty="0" smtClean="0">
+              <a:rPr lang="fr-FR" sz="6100" b="1" dirty="0">
                 <a:latin typeface="Cambria" pitchFamily="18" charset="0"/>
               </a:rPr>
               <a:t> </a:t>
             </a:r>
             <a:r>
-              <a:rPr lang="fr-FR" sz="6100" b="1" dirty="0" err="1" smtClean="0">
+              <a:rPr lang="fr-FR" sz="6100" b="1" dirty="0" err="1">
                 <a:latin typeface="Cambria" pitchFamily="18" charset="0"/>
               </a:rPr>
               <a:t>re</a:t>
             </a:r>
             <a:r>
-              <a:rPr lang="fr-FR" sz="6100" b="1" dirty="0" smtClean="0">
+              <a:rPr lang="fr-FR" sz="6100" b="1" dirty="0">
                 <a:latin typeface="Cambria" pitchFamily="18" charset="0"/>
               </a:rPr>
               <a:t> ho </a:t>
             </a:r>
             <a:r>
-              <a:rPr lang="fr-FR" sz="6100" b="1" dirty="0" err="1" smtClean="0">
+              <a:rPr lang="fr-FR" sz="6100" b="1" dirty="0" err="1">
                 <a:latin typeface="Cambria" pitchFamily="18" charset="0"/>
               </a:rPr>
               <a:t>tena</a:t>
             </a:r>
             <a:r>
-              <a:rPr lang="fr-FR" sz="6100" b="1" dirty="0" smtClean="0">
+              <a:rPr lang="fr-FR" sz="6100" b="1" dirty="0">
                 <a:latin typeface="Cambria" pitchFamily="18" charset="0"/>
               </a:rPr>
               <a:t> </a:t>
             </a:r>
             <a:r>
-              <a:rPr lang="fr-FR" sz="6100" b="1" dirty="0" err="1" smtClean="0">
+              <a:rPr lang="fr-FR" sz="6100" b="1" dirty="0" err="1">
                 <a:latin typeface="Cambria" pitchFamily="18" charset="0"/>
               </a:rPr>
               <a:t>taho</a:t>
             </a:r>
-            <a:endParaRPr lang="fr-FR" sz="6100" b="1" dirty="0" smtClean="0">
+            <a:endParaRPr lang="fr-FR" sz="6100" b="1" dirty="0">
               <a:latin typeface="Cambria" pitchFamily="18" charset="0"/>
             </a:endParaRPr>
           </a:p>
@@ -5006,31 +4909,31 @@
               <a:buNone/>
             </a:pPr>
             <a:r>
-              <a:rPr lang="fr-FR" sz="6100" b="1" dirty="0" smtClean="0">
+              <a:rPr lang="fr-FR" sz="6100" b="1" dirty="0">
                 <a:latin typeface="Cambria" pitchFamily="18" charset="0"/>
               </a:rPr>
               <a:t>'Zay </a:t>
             </a:r>
             <a:r>
-              <a:rPr lang="fr-FR" sz="6100" b="1" dirty="0" err="1" smtClean="0">
+              <a:rPr lang="fr-FR" sz="6100" b="1" dirty="0" err="1">
                 <a:latin typeface="Cambria" pitchFamily="18" charset="0"/>
               </a:rPr>
               <a:t>mikambana</a:t>
             </a:r>
             <a:r>
-              <a:rPr lang="fr-FR" sz="6100" b="1" dirty="0" smtClean="0">
+              <a:rPr lang="fr-FR" sz="6100" b="1" dirty="0">
                 <a:latin typeface="Cambria" pitchFamily="18" charset="0"/>
               </a:rPr>
               <a:t> </a:t>
             </a:r>
             <a:r>
-              <a:rPr lang="fr-FR" sz="6100" b="1" dirty="0" err="1" smtClean="0">
+              <a:rPr lang="fr-FR" sz="6100" b="1" dirty="0" err="1">
                 <a:latin typeface="Cambria" pitchFamily="18" charset="0"/>
               </a:rPr>
               <a:t>Aminao</a:t>
             </a:r>
             <a:r>
-              <a:rPr lang="fr-FR" sz="6100" b="1" dirty="0" smtClean="0">
+              <a:rPr lang="fr-FR" sz="6100" b="1" dirty="0">
                 <a:latin typeface="Cambria" pitchFamily="18" charset="0"/>
               </a:rPr>
               <a:t>,</a:t>
@@ -5041,43 +4944,43 @@
               <a:buNone/>
             </a:pPr>
             <a:r>
-              <a:rPr lang="fr-FR" sz="6100" b="1" dirty="0" smtClean="0">
+              <a:rPr lang="fr-FR" sz="6100" b="1" dirty="0">
                 <a:latin typeface="Cambria" pitchFamily="18" charset="0"/>
               </a:rPr>
               <a:t>  Ka </a:t>
             </a:r>
             <a:r>
-              <a:rPr lang="fr-FR" sz="6100" b="1" dirty="0" err="1" smtClean="0">
+              <a:rPr lang="fr-FR" sz="6100" b="1" dirty="0" err="1">
                 <a:latin typeface="Cambria" pitchFamily="18" charset="0"/>
               </a:rPr>
               <a:t>ny</a:t>
             </a:r>
             <a:r>
-              <a:rPr lang="fr-FR" sz="6100" b="1" dirty="0" smtClean="0">
+              <a:rPr lang="fr-FR" sz="6100" b="1" dirty="0">
                 <a:latin typeface="Cambria" pitchFamily="18" charset="0"/>
               </a:rPr>
               <a:t> </a:t>
             </a:r>
             <a:r>
-              <a:rPr lang="fr-FR" sz="6100" b="1" dirty="0" err="1" smtClean="0">
+              <a:rPr lang="fr-FR" sz="6100" b="1" dirty="0" err="1">
                 <a:latin typeface="Cambria" pitchFamily="18" charset="0"/>
               </a:rPr>
               <a:t>foko</a:t>
             </a:r>
             <a:r>
-              <a:rPr lang="fr-FR" sz="6100" b="1" dirty="0" smtClean="0">
+              <a:rPr lang="fr-FR" sz="6100" b="1" dirty="0">
                 <a:latin typeface="Cambria" pitchFamily="18" charset="0"/>
               </a:rPr>
               <a:t> </a:t>
             </a:r>
             <a:r>
-              <a:rPr lang="fr-FR" sz="6100" b="1" dirty="0" err="1" smtClean="0">
+              <a:rPr lang="fr-FR" sz="6100" b="1" dirty="0" err="1">
                 <a:latin typeface="Cambria" pitchFamily="18" charset="0"/>
               </a:rPr>
               <a:t>halalaho</a:t>
             </a:r>
             <a:r>
-              <a:rPr lang="fr-FR" sz="6100" b="1" dirty="0" smtClean="0">
+              <a:rPr lang="fr-FR" sz="6100" b="1" dirty="0">
                 <a:latin typeface="Cambria" pitchFamily="18" charset="0"/>
               </a:rPr>
               <a:t>,</a:t>
@@ -5088,37 +4991,31 @@
               <a:buNone/>
             </a:pPr>
             <a:r>
-              <a:rPr lang="fr-FR" sz="6100" b="1" dirty="0" smtClean="0">
+              <a:rPr lang="fr-FR" sz="6100" b="1" dirty="0">
                 <a:latin typeface="Cambria" pitchFamily="18" charset="0"/>
               </a:rPr>
               <a:t>  </a:t>
             </a:r>
             <a:r>
-              <a:rPr lang="fr-FR" sz="6100" b="1" dirty="0" err="1" smtClean="0">
+              <a:rPr lang="fr-FR" sz="6100" b="1" dirty="0" err="1">
                 <a:latin typeface="Cambria" pitchFamily="18" charset="0"/>
               </a:rPr>
               <a:t>Diovy</a:t>
             </a:r>
             <a:r>
-              <a:rPr lang="fr-FR" sz="6100" b="1" dirty="0" smtClean="0">
-                <a:latin typeface="Cambria" pitchFamily="18" charset="0"/>
-              </a:rPr>
-              <a:t> </a:t>
-            </a:r>
-            <a:r>
-              <a:rPr lang="fr-FR" sz="6100" b="1" dirty="0" smtClean="0">
-                <a:latin typeface="Cambria" pitchFamily="18" charset="0"/>
-              </a:rPr>
-              <a:t>ho </a:t>
-            </a:r>
-            <a:r>
-              <a:rPr lang="fr-FR" sz="6100" b="1" dirty="0" err="1" smtClean="0">
+              <a:rPr lang="fr-FR" sz="6100" b="1" dirty="0">
+                <a:latin typeface="Cambria" pitchFamily="18" charset="0"/>
+              </a:rPr>
+              <a:t> ho </a:t>
+            </a:r>
+            <a:r>
+              <a:rPr lang="fr-FR" sz="6100" b="1" dirty="0" err="1">
                 <a:latin typeface="Cambria" pitchFamily="18" charset="0"/>
               </a:rPr>
               <a:t>Tempolinao</a:t>
             </a:r>
             <a:r>
-              <a:rPr lang="fr-FR" sz="6100" b="1" dirty="0" smtClean="0">
+              <a:rPr lang="fr-FR" sz="6100" b="1" dirty="0">
                 <a:latin typeface="Cambria" pitchFamily="18" charset="0"/>
               </a:rPr>
               <a:t>.</a:t>
@@ -5129,7 +5026,7 @@
               <a:buNone/>
             </a:pPr>
             <a:r>
-              <a:rPr lang="fr-FR" sz="6100" b="1" dirty="0" smtClean="0">
+              <a:rPr lang="fr-FR" sz="6100" b="1" dirty="0">
                 <a:latin typeface="Cambria" pitchFamily="18" charset="0"/>
               </a:rPr>
               <a:t> </a:t>
@@ -5150,13 +5047,6 @@
   <p:clrMapOvr>
     <a:overrideClrMapping bg1="lt1" tx1="dk1" bg2="lt2" tx2="dk2" accent1="accent1" accent2="accent2" accent3="accent3" accent4="accent4" accent5="accent5" accent6="accent6" hlink="hlink" folHlink="folHlink"/>
   </p:clrMapOvr>
-  <p:timing>
-    <p:tnLst>
-      <p:par>
-        <p:cTn id="1" dur="indefinite" restart="never" nodeType="tmRoot"/>
-      </p:par>
-    </p:tnLst>
-  </p:timing>
 </p:sld>
 </file>
 

</xml_diff>